<commit_message>
Adding training materials and study materials.
</commit_message>
<xml_diff>
--- a/yocto_training_all_session_decks/session_decks/D1S4_Embedded_Linux_Landscape.pptx
+++ b/yocto_training_all_session_decks/session_decks/D1S4_Embedded_Linux_Landscape.pptx
@@ -5,25 +5,25 @@
     <p:sldMasterId id="2147483648" r:id="rId1"/>
   </p:sldMasterIdLst>
   <p:notesMasterIdLst>
-    <p:notesMasterId r:id="rId8"/>
+    <p:notesMasterId r:id="rId10"/>
   </p:notesMasterIdLst>
   <p:handoutMasterIdLst>
-    <p:handoutMasterId r:id="rId9"/>
+    <p:handoutMasterId r:id="rId11"/>
   </p:handoutMasterIdLst>
   <p:sldIdLst>
-    <p:sldId id="1007" r:id="rId18"/>
-    <p:sldId id="1008" r:id="rId19"/>
-    <p:sldId id="1009" r:id="rId20"/>
-    <p:sldId id="1010" r:id="rId21"/>
-    <p:sldId id="1011" r:id="rId22"/>
-    <p:sldId id="1012" r:id="rId23"/>
-    <p:sldId id="1013" r:id="rId24"/>
-    <p:sldId id="1014" r:id="rId25"/>
+    <p:sldId id="1007" r:id="rId2"/>
+    <p:sldId id="1008" r:id="rId3"/>
+    <p:sldId id="1009" r:id="rId4"/>
+    <p:sldId id="1010" r:id="rId5"/>
+    <p:sldId id="1011" r:id="rId6"/>
+    <p:sldId id="1012" r:id="rId7"/>
+    <p:sldId id="1013" r:id="rId8"/>
+    <p:sldId id="1014" r:id="rId9"/>
   </p:sldIdLst>
   <p:sldSz cx="12192000" cy="6858000"/>
   <p:notesSz cx="6858000" cy="9144000"/>
   <p:custDataLst>
-    <p:tags r:id="rId10"/>
+    <p:tags r:id="rId12"/>
   </p:custDataLst>
   <p:defaultTextStyle>
     <a:defPPr>
@@ -2929,7 +2929,7 @@
           <a:p>
             <a:fld id="{0CEC647C-F50C-4F78-AA33-D7AA6CDA18EE}" type="datetimeFigureOut">
               <a:rPr lang="en-US" smtClean="0"/>
-              <a:t>7/13/2025</a:t>
+              <a:t>5/30/2026</a:t>
             </a:fld>
             <a:endParaRPr lang="en-US"/>
           </a:p>
@@ -3094,7 +3094,7 @@
           <a:p>
             <a:fld id="{3A83341F-E62C-483B-84B4-966F8BE46097}" type="datetimeFigureOut">
               <a:rPr lang="en-US" smtClean="0"/>
-              <a:t>7/13/2025</a:t>
+              <a:t>5/30/2026</a:t>
             </a:fld>
             <a:endParaRPr lang="en-US"/>
           </a:p>
@@ -5178,8 +5178,8 @@
 </p:sldMaster>
 </file>
 
-<file path=ppt/slides/slide10.xml><?xml version="1.0" encoding="utf-8"?>
-<p:sld xmlns:a="http://schemas.openxmlformats.org/drawingml/2006/main" xmlns:p="http://schemas.openxmlformats.org/presentationml/2006/main" xmlns:r="http://schemas.openxmlformats.org/officeDocument/2006/relationships">
+<file path=ppt/slides/slide1.xml><?xml version="1.0" encoding="utf-8"?>
+<p:sld xmlns:a="http://schemas.openxmlformats.org/drawingml/2006/main" xmlns:r="http://schemas.openxmlformats.org/officeDocument/2006/relationships" xmlns:p="http://schemas.openxmlformats.org/presentationml/2006/main">
   <p:cSld>
     <p:spTree>
       <p:nvGrpSpPr>
@@ -5187,7 +5187,111 @@
         <p:cNvGrpSpPr/>
         <p:nvPr/>
       </p:nvGrpSpPr>
-      <p:grpSpPr/>
+      <p:grpSpPr>
+        <a:xfrm>
+          <a:off x="0" y="0"/>
+          <a:ext cx="0" cy="0"/>
+          <a:chOff x="0" y="0"/>
+          <a:chExt cx="0" cy="0"/>
+        </a:xfrm>
+      </p:grpSpPr>
+      <p:sp>
+        <p:nvSpPr>
+          <p:cNvPr id="2" name="Title 1"/>
+          <p:cNvSpPr>
+            <a:spLocks noGrp="1"/>
+          </p:cNvSpPr>
+          <p:nvPr>
+            <p:ph type="ctrTitle"/>
+          </p:nvPr>
+        </p:nvSpPr>
+        <p:spPr/>
+        <p:txBody>
+          <a:bodyPr/>
+          <a:lstStyle/>
+          <a:p>
+            <a:r>
+              <a:rPr sz="4400" b="1">
+                <a:solidFill>
+                  <a:srgbClr val="FFFFFF"/>
+                </a:solidFill>
+                <a:latin typeface="Calibri"/>
+              </a:rPr>
+              <a:t>Embedded Linux Landscape</a:t>
+            </a:r>
+          </a:p>
+        </p:txBody>
+      </p:sp>
+      <p:sp>
+        <p:nvSpPr>
+          <p:cNvPr id="3" name="Subtitle 2"/>
+          <p:cNvSpPr>
+            <a:spLocks noGrp="1"/>
+          </p:cNvSpPr>
+          <p:nvPr>
+            <p:ph type="subTitle" idx="1"/>
+          </p:nvPr>
+        </p:nvSpPr>
+        <p:spPr/>
+        <p:txBody>
+          <a:bodyPr/>
+          <a:lstStyle/>
+          <a:p>
+            <a:r>
+              <a:rPr sz="1800" dirty="0">
+                <a:solidFill>
+                  <a:srgbClr val="FFFFFF"/>
+                </a:solidFill>
+                <a:latin typeface="Calibri"/>
+              </a:rPr>
+              <a:t>Where </a:t>
+            </a:r>
+            <a:r>
+              <a:rPr sz="1800" dirty="0" err="1">
+                <a:solidFill>
+                  <a:srgbClr val="FFFFFF"/>
+                </a:solidFill>
+                <a:latin typeface="Calibri"/>
+              </a:rPr>
+              <a:t>Yocto</a:t>
+            </a:r>
+            <a:r>
+              <a:rPr sz="1800" dirty="0">
+                <a:solidFill>
+                  <a:srgbClr val="FFFFFF"/>
+                </a:solidFill>
+                <a:latin typeface="Calibri"/>
+              </a:rPr>
+              <a:t> fits in the ecosystem</a:t>
+            </a:r>
+          </a:p>
+        </p:txBody>
+      </p:sp>
+    </p:spTree>
+  </p:cSld>
+  <p:clrMapOvr>
+    <a:masterClrMapping/>
+  </p:clrMapOvr>
+</p:sld>
+</file>
+
+<file path=ppt/slides/slide2.xml><?xml version="1.0" encoding="utf-8"?>
+<p:sld xmlns:a="http://schemas.openxmlformats.org/drawingml/2006/main" xmlns:r="http://schemas.openxmlformats.org/officeDocument/2006/relationships" xmlns:p="http://schemas.openxmlformats.org/presentationml/2006/main">
+  <p:cSld>
+    <p:spTree>
+      <p:nvGrpSpPr>
+        <p:cNvPr id="1" name=""/>
+        <p:cNvGrpSpPr/>
+        <p:nvPr/>
+      </p:nvGrpSpPr>
+      <p:grpSpPr>
+        <a:xfrm>
+          <a:off x="0" y="0"/>
+          <a:ext cx="0" cy="0"/>
+          <a:chOff x="0" y="0"/>
+          <a:chExt cx="0" cy="0"/>
+        </a:xfrm>
+      </p:grpSpPr>
       <p:sp>
         <p:nvSpPr>
           <p:cNvPr id="2" name="Title 1"/>
@@ -5204,13 +5308,216 @@
           <a:lstStyle/>
           <a:p>
             <a:r>
-              <a:rPr sz="3200" b="1">
-                <a:solidFill>
-                  <a:srgbClr val="CC0066"/>
-                </a:solidFill>
-                <a:latin typeface="Calibri"/>
-              </a:rPr>
-              <a:t>Buildroot vs Yocto</a:t>
+              <a:rPr sz="3200" b="1" dirty="0">
+                <a:latin typeface="Calibri"/>
+              </a:rPr>
+              <a:t>Session Agenda</a:t>
+            </a:r>
+          </a:p>
+        </p:txBody>
+      </p:sp>
+      <p:sp>
+        <p:nvSpPr>
+          <p:cNvPr id="3" name="TextBox 2"/>
+          <p:cNvSpPr txBox="1"/>
+          <p:nvPr/>
+        </p:nvSpPr>
+        <p:spPr>
+          <a:xfrm>
+            <a:off x="822960" y="1463040"/>
+            <a:ext cx="10515600" cy="5029200"/>
+          </a:xfrm>
+          <a:prstGeom prst="rect">
+            <a:avLst/>
+          </a:prstGeom>
+          <a:noFill/>
+        </p:spPr>
+        <p:txBody>
+          <a:bodyPr wrap="square" lIns="45720" rIns="45720">
+            <a:spAutoFit/>
+          </a:bodyPr>
+          <a:lstStyle/>
+          <a:p>
+            <a:pPr>
+              <a:spcAft>
+                <a:spcPts val="600"/>
+              </a:spcAft>
+            </a:pPr>
+            <a:r>
+              <a:rPr sz="2000" b="0" i="0" dirty="0">
+                <a:solidFill>
+                  <a:srgbClr val="333333"/>
+                </a:solidFill>
+                <a:latin typeface="Calibri"/>
+              </a:rPr>
+              <a:t>1.  The embedded Linux problem</a:t>
+            </a:r>
+          </a:p>
+          <a:p>
+            <a:pPr>
+              <a:spcAft>
+                <a:spcPts val="600"/>
+              </a:spcAft>
+            </a:pPr>
+            <a:r>
+              <a:rPr sz="2000" b="0" i="0" dirty="0">
+                <a:solidFill>
+                  <a:srgbClr val="333333"/>
+                </a:solidFill>
+                <a:latin typeface="Calibri"/>
+              </a:rPr>
+              <a:t>2.  </a:t>
+            </a:r>
+            <a:r>
+              <a:rPr sz="2000" b="0" i="0" dirty="0" err="1">
+                <a:solidFill>
+                  <a:srgbClr val="333333"/>
+                </a:solidFill>
+                <a:latin typeface="Calibri"/>
+              </a:rPr>
+              <a:t>Buildroot</a:t>
+            </a:r>
+            <a:r>
+              <a:rPr sz="2000" b="0" i="0" dirty="0">
+                <a:solidFill>
+                  <a:srgbClr val="333333"/>
+                </a:solidFill>
+                <a:latin typeface="Calibri"/>
+              </a:rPr>
+              <a:t> vs </a:t>
+            </a:r>
+            <a:r>
+              <a:rPr sz="2000" b="0" i="0" dirty="0" err="1">
+                <a:solidFill>
+                  <a:srgbClr val="333333"/>
+                </a:solidFill>
+                <a:latin typeface="Calibri"/>
+              </a:rPr>
+              <a:t>Yocto</a:t>
+            </a:r>
+            <a:r>
+              <a:rPr sz="2000" b="0" i="0" dirty="0">
+                <a:solidFill>
+                  <a:srgbClr val="333333"/>
+                </a:solidFill>
+                <a:latin typeface="Calibri"/>
+              </a:rPr>
+              <a:t> — the two main contenders</a:t>
+            </a:r>
+          </a:p>
+          <a:p>
+            <a:pPr>
+              <a:spcAft>
+                <a:spcPts val="600"/>
+              </a:spcAft>
+            </a:pPr>
+            <a:r>
+              <a:rPr sz="2000" b="0" i="0" dirty="0">
+                <a:solidFill>
+                  <a:srgbClr val="333333"/>
+                </a:solidFill>
+                <a:latin typeface="Calibri"/>
+              </a:rPr>
+              <a:t>3.  When to pick which</a:t>
+            </a:r>
+          </a:p>
+          <a:p>
+            <a:pPr>
+              <a:spcAft>
+                <a:spcPts val="600"/>
+              </a:spcAft>
+            </a:pPr>
+            <a:r>
+              <a:rPr sz="2000" b="0" i="0" dirty="0">
+                <a:solidFill>
+                  <a:srgbClr val="333333"/>
+                </a:solidFill>
+                <a:latin typeface="Calibri"/>
+              </a:rPr>
+              <a:t>4.  Cross-compilation fundamentals</a:t>
+            </a:r>
+          </a:p>
+          <a:p>
+            <a:pPr>
+              <a:spcAft>
+                <a:spcPts val="600"/>
+              </a:spcAft>
+            </a:pPr>
+            <a:r>
+              <a:rPr sz="2000" b="0" i="0" dirty="0">
+                <a:solidFill>
+                  <a:srgbClr val="333333"/>
+                </a:solidFill>
+                <a:latin typeface="Calibri"/>
+              </a:rPr>
+              <a:t>5.  Toolchain, </a:t>
+            </a:r>
+            <a:r>
+              <a:rPr sz="2000" b="0" i="0" dirty="0" err="1">
+                <a:solidFill>
+                  <a:srgbClr val="333333"/>
+                </a:solidFill>
+                <a:latin typeface="Calibri"/>
+              </a:rPr>
+              <a:t>sysroot</a:t>
+            </a:r>
+            <a:r>
+              <a:rPr sz="2000" b="0" i="0" dirty="0">
+                <a:solidFill>
+                  <a:srgbClr val="333333"/>
+                </a:solidFill>
+                <a:latin typeface="Calibri"/>
+              </a:rPr>
+              <a:t>, ABI, target triples</a:t>
+            </a:r>
+          </a:p>
+        </p:txBody>
+      </p:sp>
+    </p:spTree>
+  </p:cSld>
+  <p:clrMapOvr>
+    <a:masterClrMapping/>
+  </p:clrMapOvr>
+</p:sld>
+</file>
+
+<file path=ppt/slides/slide3.xml><?xml version="1.0" encoding="utf-8"?>
+<p:sld xmlns:a="http://schemas.openxmlformats.org/drawingml/2006/main" xmlns:r="http://schemas.openxmlformats.org/officeDocument/2006/relationships" xmlns:p="http://schemas.openxmlformats.org/presentationml/2006/main">
+  <p:cSld>
+    <p:spTree>
+      <p:nvGrpSpPr>
+        <p:cNvPr id="1" name=""/>
+        <p:cNvGrpSpPr/>
+        <p:nvPr/>
+      </p:nvGrpSpPr>
+      <p:grpSpPr>
+        <a:xfrm>
+          <a:off x="0" y="0"/>
+          <a:ext cx="0" cy="0"/>
+          <a:chOff x="0" y="0"/>
+          <a:chExt cx="0" cy="0"/>
+        </a:xfrm>
+      </p:grpSpPr>
+      <p:sp>
+        <p:nvSpPr>
+          <p:cNvPr id="2" name="Title 1"/>
+          <p:cNvSpPr>
+            <a:spLocks noGrp="1"/>
+          </p:cNvSpPr>
+          <p:nvPr>
+            <p:ph type="title"/>
+          </p:nvPr>
+        </p:nvSpPr>
+        <p:spPr/>
+        <p:txBody>
+          <a:bodyPr/>
+          <a:lstStyle/>
+          <a:p>
+            <a:r>
+              <a:rPr sz="3200" b="1" dirty="0">
+                <a:latin typeface="Calibri"/>
+              </a:rPr>
+              <a:t>The Embedded Linux Problem</a:t>
             </a:r>
           </a:p>
         </p:txBody>
@@ -5224,7 +5531,7 @@
         <p:spPr>
           <a:xfrm>
             <a:off x="822960" y="1417320"/>
-            <a:ext cx="10515600" cy="365760"/>
+            <a:ext cx="10515600" cy="338554"/>
           </a:xfrm>
           <a:prstGeom prst="rect">
             <a:avLst/>
@@ -5232,14 +5539,364 @@
           <a:noFill/>
         </p:spPr>
         <p:txBody>
-          <a:bodyPr wrap="square" anchor="t" lIns="45720" rIns="45720">
+          <a:bodyPr wrap="square" lIns="45720" rIns="45720" anchor="t">
             <a:spAutoFit/>
           </a:bodyPr>
           <a:lstStyle/>
           <a:p>
             <a:pPr algn="l"/>
             <a:r>
-              <a:rPr sz="1500" b="0" i="1">
+              <a:rPr sz="1600" b="0" i="1" dirty="0">
+                <a:solidFill>
+                  <a:srgbClr val="666666"/>
+                </a:solidFill>
+                <a:latin typeface="Calibri"/>
+              </a:rPr>
+              <a:t>Why we can't just 'apt install' our way to an embedded device.</a:t>
+            </a:r>
+          </a:p>
+        </p:txBody>
+      </p:sp>
+      <p:sp>
+        <p:nvSpPr>
+          <p:cNvPr id="4" name="TextBox 3"/>
+          <p:cNvSpPr txBox="1"/>
+          <p:nvPr/>
+        </p:nvSpPr>
+        <p:spPr>
+          <a:xfrm>
+            <a:off x="822960" y="1783080"/>
+            <a:ext cx="10515600" cy="3888244"/>
+          </a:xfrm>
+          <a:prstGeom prst="rect">
+            <a:avLst/>
+          </a:prstGeom>
+          <a:noFill/>
+        </p:spPr>
+        <p:txBody>
+          <a:bodyPr wrap="square" lIns="45720" rIns="45720">
+            <a:spAutoFit/>
+          </a:bodyPr>
+          <a:lstStyle/>
+          <a:p>
+            <a:pPr>
+              <a:spcAft>
+                <a:spcPts val="400"/>
+              </a:spcAft>
+            </a:pPr>
+            <a:r>
+              <a:rPr sz="2000" b="1" i="0" dirty="0">
+                <a:solidFill>
+                  <a:srgbClr val="CC0066"/>
+                </a:solidFill>
+                <a:latin typeface="Calibri"/>
+              </a:rPr>
+              <a:t>Desktop Linux assumes</a:t>
+            </a:r>
+          </a:p>
+          <a:p>
+            <a:pPr>
+              <a:spcAft>
+                <a:spcPts val="400"/>
+              </a:spcAft>
+            </a:pPr>
+            <a:r>
+              <a:rPr sz="1600" b="0" i="0" dirty="0">
+                <a:solidFill>
+                  <a:srgbClr val="333333"/>
+                </a:solidFill>
+                <a:latin typeface="Calibri"/>
+              </a:rPr>
+              <a:t>• Lots of RAM, lots of disk</a:t>
+            </a:r>
+          </a:p>
+          <a:p>
+            <a:pPr>
+              <a:spcAft>
+                <a:spcPts val="400"/>
+              </a:spcAft>
+            </a:pPr>
+            <a:r>
+              <a:rPr sz="1600" b="0" i="0" dirty="0">
+                <a:solidFill>
+                  <a:srgbClr val="333333"/>
+                </a:solidFill>
+                <a:latin typeface="Calibri"/>
+              </a:rPr>
+              <a:t>• A package manager with network access</a:t>
+            </a:r>
+          </a:p>
+          <a:p>
+            <a:pPr>
+              <a:spcAft>
+                <a:spcPts val="400"/>
+              </a:spcAft>
+            </a:pPr>
+            <a:r>
+              <a:rPr sz="1600" b="0" i="0" dirty="0">
+                <a:solidFill>
+                  <a:srgbClr val="333333"/>
+                </a:solidFill>
+                <a:latin typeface="Calibri"/>
+              </a:rPr>
+              <a:t>• Generic x86_64 hardware</a:t>
+            </a:r>
+          </a:p>
+          <a:p>
+            <a:pPr>
+              <a:spcAft>
+                <a:spcPts val="1000"/>
+              </a:spcAft>
+            </a:pPr>
+            <a:r>
+              <a:rPr sz="1600" b="0" i="0" dirty="0">
+                <a:solidFill>
+                  <a:srgbClr val="333333"/>
+                </a:solidFill>
+                <a:latin typeface="Calibri"/>
+              </a:rPr>
+              <a:t>• Someone is sitting at a keyboard</a:t>
+            </a:r>
+          </a:p>
+          <a:p>
+            <a:pPr>
+              <a:spcAft>
+                <a:spcPts val="400"/>
+              </a:spcAft>
+            </a:pPr>
+            <a:r>
+              <a:rPr sz="2000" b="1" i="0" dirty="0">
+                <a:solidFill>
+                  <a:srgbClr val="663399"/>
+                </a:solidFill>
+                <a:latin typeface="Calibri"/>
+              </a:rPr>
+              <a:t>Embedded Linux reality</a:t>
+            </a:r>
+          </a:p>
+          <a:p>
+            <a:pPr>
+              <a:spcAft>
+                <a:spcPts val="400"/>
+              </a:spcAft>
+            </a:pPr>
+            <a:r>
+              <a:rPr sz="1600" b="0" i="0" dirty="0">
+                <a:solidFill>
+                  <a:srgbClr val="333333"/>
+                </a:solidFill>
+                <a:latin typeface="Calibri"/>
+              </a:rPr>
+              <a:t>• Tight resources — 256 MB RAM, 1 GB flash is common</a:t>
+            </a:r>
+          </a:p>
+          <a:p>
+            <a:pPr>
+              <a:spcAft>
+                <a:spcPts val="400"/>
+              </a:spcAft>
+            </a:pPr>
+            <a:r>
+              <a:rPr sz="1600" b="0" i="0" dirty="0">
+                <a:solidFill>
+                  <a:srgbClr val="333333"/>
+                </a:solidFill>
+                <a:latin typeface="Calibri"/>
+              </a:rPr>
+              <a:t>• Custom hardware — ARM SoC, specific peripherals</a:t>
+            </a:r>
+          </a:p>
+          <a:p>
+            <a:pPr>
+              <a:spcAft>
+                <a:spcPts val="400"/>
+              </a:spcAft>
+            </a:pPr>
+            <a:r>
+              <a:rPr sz="1600" b="0" i="0" dirty="0">
+                <a:solidFill>
+                  <a:srgbClr val="333333"/>
+                </a:solidFill>
+                <a:latin typeface="Calibri"/>
+              </a:rPr>
+              <a:t>• Headless — no keyboard, often no display</a:t>
+            </a:r>
+          </a:p>
+          <a:p>
+            <a:pPr>
+              <a:spcAft>
+                <a:spcPts val="400"/>
+              </a:spcAft>
+            </a:pPr>
+            <a:r>
+              <a:rPr sz="1600" b="0" i="0" dirty="0">
+                <a:solidFill>
+                  <a:srgbClr val="333333"/>
+                </a:solidFill>
+                <a:latin typeface="Calibri"/>
+              </a:rPr>
+              <a:t>• Cross-compiled — build on x86, run on ARM</a:t>
+            </a:r>
+          </a:p>
+          <a:p>
+            <a:pPr>
+              <a:spcAft>
+                <a:spcPts val="1000"/>
+              </a:spcAft>
+            </a:pPr>
+            <a:r>
+              <a:rPr sz="1600" b="0" i="0" dirty="0">
+                <a:solidFill>
+                  <a:srgbClr val="333333"/>
+                </a:solidFill>
+                <a:latin typeface="Calibri"/>
+              </a:rPr>
+              <a:t>• Customer-shipped — must be reproducible, supportable for years</a:t>
+            </a:r>
+          </a:p>
+          <a:p>
+            <a:pPr>
+              <a:spcAft>
+                <a:spcPts val="400"/>
+              </a:spcAft>
+            </a:pPr>
+            <a:r>
+              <a:rPr b="1" i="0" dirty="0">
+                <a:solidFill>
+                  <a:srgbClr val="663399"/>
+                </a:solidFill>
+                <a:latin typeface="Calibri"/>
+              </a:rPr>
+              <a:t>So we need a build system that handles all of this end to end. That's where </a:t>
+            </a:r>
+            <a:r>
+              <a:rPr b="1" i="0" dirty="0" err="1">
+                <a:solidFill>
+                  <a:srgbClr val="663399"/>
+                </a:solidFill>
+                <a:latin typeface="Calibri"/>
+              </a:rPr>
+              <a:t>Buildroot</a:t>
+            </a:r>
+            <a:r>
+              <a:rPr b="1" i="0" dirty="0">
+                <a:solidFill>
+                  <a:srgbClr val="663399"/>
+                </a:solidFill>
+                <a:latin typeface="Calibri"/>
+              </a:rPr>
+              <a:t> and </a:t>
+            </a:r>
+            <a:r>
+              <a:rPr b="1" i="0" dirty="0" err="1">
+                <a:solidFill>
+                  <a:srgbClr val="663399"/>
+                </a:solidFill>
+                <a:latin typeface="Calibri"/>
+              </a:rPr>
+              <a:t>Yocto</a:t>
+            </a:r>
+            <a:r>
+              <a:rPr b="1" i="0" dirty="0">
+                <a:solidFill>
+                  <a:srgbClr val="663399"/>
+                </a:solidFill>
+                <a:latin typeface="Calibri"/>
+              </a:rPr>
+              <a:t> come in.</a:t>
+            </a:r>
+          </a:p>
+        </p:txBody>
+      </p:sp>
+    </p:spTree>
+  </p:cSld>
+  <p:clrMapOvr>
+    <a:masterClrMapping/>
+  </p:clrMapOvr>
+</p:sld>
+</file>
+
+<file path=ppt/slides/slide4.xml><?xml version="1.0" encoding="utf-8"?>
+<p:sld xmlns:a="http://schemas.openxmlformats.org/drawingml/2006/main" xmlns:r="http://schemas.openxmlformats.org/officeDocument/2006/relationships" xmlns:p="http://schemas.openxmlformats.org/presentationml/2006/main">
+  <p:cSld>
+    <p:spTree>
+      <p:nvGrpSpPr>
+        <p:cNvPr id="1" name=""/>
+        <p:cNvGrpSpPr/>
+        <p:nvPr/>
+      </p:nvGrpSpPr>
+      <p:grpSpPr>
+        <a:xfrm>
+          <a:off x="0" y="0"/>
+          <a:ext cx="0" cy="0"/>
+          <a:chOff x="0" y="0"/>
+          <a:chExt cx="0" cy="0"/>
+        </a:xfrm>
+      </p:grpSpPr>
+      <p:sp>
+        <p:nvSpPr>
+          <p:cNvPr id="2" name="Title 1"/>
+          <p:cNvSpPr>
+            <a:spLocks noGrp="1"/>
+          </p:cNvSpPr>
+          <p:nvPr>
+            <p:ph type="title"/>
+          </p:nvPr>
+        </p:nvSpPr>
+        <p:spPr/>
+        <p:txBody>
+          <a:bodyPr/>
+          <a:lstStyle/>
+          <a:p>
+            <a:r>
+              <a:rPr sz="3200" b="1" dirty="0" err="1">
+                <a:latin typeface="Calibri"/>
+              </a:rPr>
+              <a:t>Buildroot</a:t>
+            </a:r>
+            <a:r>
+              <a:rPr sz="3200" b="1" dirty="0">
+                <a:latin typeface="Calibri"/>
+              </a:rPr>
+              <a:t> vs </a:t>
+            </a:r>
+            <a:r>
+              <a:rPr sz="3200" b="1" dirty="0" err="1">
+                <a:latin typeface="Calibri"/>
+              </a:rPr>
+              <a:t>Yocto</a:t>
+            </a:r>
+            <a:endParaRPr sz="3200" b="1" dirty="0">
+              <a:latin typeface="Calibri"/>
+            </a:endParaRPr>
+          </a:p>
+        </p:txBody>
+      </p:sp>
+      <p:sp>
+        <p:nvSpPr>
+          <p:cNvPr id="3" name="TextBox 2"/>
+          <p:cNvSpPr txBox="1"/>
+          <p:nvPr/>
+        </p:nvSpPr>
+        <p:spPr>
+          <a:xfrm>
+            <a:off x="822960" y="1417320"/>
+            <a:ext cx="10515600" cy="338554"/>
+          </a:xfrm>
+          <a:prstGeom prst="rect">
+            <a:avLst/>
+          </a:prstGeom>
+          <a:noFill/>
+        </p:spPr>
+        <p:txBody>
+          <a:bodyPr wrap="square" lIns="45720" rIns="45720" anchor="t">
+            <a:spAutoFit/>
+          </a:bodyPr>
+          <a:lstStyle/>
+          <a:p>
+            <a:pPr algn="l"/>
+            <a:r>
+              <a:rPr sz="1600" b="0" i="1" dirty="0">
                 <a:solidFill>
                   <a:srgbClr val="666666"/>
                 </a:solidFill>
@@ -5293,6 +5950,7 @@
           <a:lstStyle/>
           <a:p>
             <a:pPr algn="ctr"/>
+            <a:endParaRPr/>
           </a:p>
         </p:txBody>
       </p:sp>
@@ -5313,7 +5971,7 @@
           <a:noFill/>
         </p:spPr>
         <p:txBody>
-          <a:bodyPr wrap="square" anchor="t" lIns="45720" rIns="45720">
+          <a:bodyPr wrap="square" lIns="45720" rIns="45720" anchor="t">
             <a:spAutoFit/>
           </a:bodyPr>
           <a:lstStyle/>
@@ -5340,7 +5998,7 @@
         <p:spPr>
           <a:xfrm>
             <a:off x="960120" y="2468880"/>
-            <a:ext cx="4937760" cy="3794760"/>
+            <a:ext cx="4937760" cy="3559949"/>
           </a:xfrm>
           <a:prstGeom prst="rect">
             <a:avLst/>
@@ -5359,7 +6017,7 @@
               </a:spcAft>
             </a:pPr>
             <a:r>
-              <a:rPr sz="1400" b="1" i="0">
+              <a:rPr b="1" i="0">
                 <a:solidFill>
                   <a:srgbClr val="CC0066"/>
                 </a:solidFill>
@@ -5375,7 +6033,7 @@
               </a:spcAft>
             </a:pPr>
             <a:r>
-              <a:rPr sz="1200" b="0" i="0">
+              <a:rPr sz="1600" b="0" i="0">
                 <a:solidFill>
                   <a:srgbClr val="333333"/>
                 </a:solidFill>
@@ -5391,7 +6049,7 @@
               </a:spcAft>
             </a:pPr>
             <a:r>
-              <a:rPr sz="1400" b="1" i="0">
+              <a:rPr b="1" i="0">
                 <a:solidFill>
                   <a:srgbClr val="CC0066"/>
                 </a:solidFill>
@@ -5407,7 +6065,7 @@
               </a:spcAft>
             </a:pPr>
             <a:r>
-              <a:rPr sz="1200" b="0" i="0">
+              <a:rPr sz="1600" b="0" i="0">
                 <a:solidFill>
                   <a:srgbClr val="333333"/>
                 </a:solidFill>
@@ -5423,7 +6081,7 @@
               </a:spcAft>
             </a:pPr>
             <a:r>
-              <a:rPr sz="1200" b="0" i="0">
+              <a:rPr sz="1600" b="0" i="0">
                 <a:solidFill>
                   <a:srgbClr val="333333"/>
                 </a:solidFill>
@@ -5439,7 +6097,7 @@
               </a:spcAft>
             </a:pPr>
             <a:r>
-              <a:rPr sz="1200" b="0" i="0">
+              <a:rPr sz="1600" b="0" i="0">
                 <a:solidFill>
                   <a:srgbClr val="333333"/>
                 </a:solidFill>
@@ -5455,7 +6113,7 @@
               </a:spcAft>
             </a:pPr>
             <a:r>
-              <a:rPr sz="1200" b="0" i="0">
+              <a:rPr sz="1600" b="0" i="0">
                 <a:solidFill>
                   <a:srgbClr val="333333"/>
                 </a:solidFill>
@@ -5471,7 +6129,7 @@
               </a:spcAft>
             </a:pPr>
             <a:r>
-              <a:rPr sz="1400" b="1" i="0">
+              <a:rPr b="1" i="0">
                 <a:solidFill>
                   <a:srgbClr val="CC0066"/>
                 </a:solidFill>
@@ -5487,7 +6145,7 @@
               </a:spcAft>
             </a:pPr>
             <a:r>
-              <a:rPr sz="1200" b="0" i="0">
+              <a:rPr sz="1600" b="0" i="0">
                 <a:solidFill>
                   <a:srgbClr val="333333"/>
                 </a:solidFill>
@@ -5503,7 +6161,7 @@
               </a:spcAft>
             </a:pPr>
             <a:r>
-              <a:rPr sz="1200" b="0" i="0">
+              <a:rPr sz="1600" b="0" i="0">
                 <a:solidFill>
                   <a:srgbClr val="333333"/>
                 </a:solidFill>
@@ -5519,7 +6177,7 @@
               </a:spcAft>
             </a:pPr>
             <a:r>
-              <a:rPr sz="1200" b="0" i="0">
+              <a:rPr sz="1600" b="0" i="0">
                 <a:solidFill>
                   <a:srgbClr val="333333"/>
                 </a:solidFill>
@@ -5573,6 +6231,7 @@
           <a:lstStyle/>
           <a:p>
             <a:pPr algn="ctr"/>
+            <a:endParaRPr/>
           </a:p>
         </p:txBody>
       </p:sp>
@@ -5593,7 +6252,7 @@
           <a:noFill/>
         </p:spPr>
         <p:txBody>
-          <a:bodyPr wrap="square" anchor="t" lIns="45720" rIns="45720">
+          <a:bodyPr wrap="square" lIns="45720" rIns="45720" anchor="t">
             <a:spAutoFit/>
           </a:bodyPr>
           <a:lstStyle/>
@@ -5620,7 +6279,7 @@
         <p:spPr>
           <a:xfrm>
             <a:off x="6400800" y="2468880"/>
-            <a:ext cx="4937760" cy="3794760"/>
+            <a:ext cx="4937760" cy="3559949"/>
           </a:xfrm>
           <a:prstGeom prst="rect">
             <a:avLst/>
@@ -5639,7 +6298,7 @@
               </a:spcAft>
             </a:pPr>
             <a:r>
-              <a:rPr sz="1400" b="1" i="0">
+              <a:rPr b="1" i="0">
                 <a:solidFill>
                   <a:srgbClr val="663399"/>
                 </a:solidFill>
@@ -5655,7 +6314,7 @@
               </a:spcAft>
             </a:pPr>
             <a:r>
-              <a:rPr sz="1200" b="0" i="0">
+              <a:rPr sz="1600" b="0" i="0">
                 <a:solidFill>
                   <a:srgbClr val="333333"/>
                 </a:solidFill>
@@ -5671,7 +6330,7 @@
               </a:spcAft>
             </a:pPr>
             <a:r>
-              <a:rPr sz="1400" b="1" i="0">
+              <a:rPr b="1" i="0">
                 <a:solidFill>
                   <a:srgbClr val="663399"/>
                 </a:solidFill>
@@ -5687,7 +6346,7 @@
               </a:spcAft>
             </a:pPr>
             <a:r>
-              <a:rPr sz="1200" b="0" i="0">
+              <a:rPr sz="1600" b="0" i="0">
                 <a:solidFill>
                   <a:srgbClr val="333333"/>
                 </a:solidFill>
@@ -5703,7 +6362,7 @@
               </a:spcAft>
             </a:pPr>
             <a:r>
-              <a:rPr sz="1200" b="0" i="0">
+              <a:rPr sz="1600" b="0" i="0">
                 <a:solidFill>
                   <a:srgbClr val="333333"/>
                 </a:solidFill>
@@ -5719,7 +6378,7 @@
               </a:spcAft>
             </a:pPr>
             <a:r>
-              <a:rPr sz="1200" b="0" i="0">
+              <a:rPr sz="1600" b="0" i="0">
                 <a:solidFill>
                   <a:srgbClr val="333333"/>
                 </a:solidFill>
@@ -5735,7 +6394,7 @@
               </a:spcAft>
             </a:pPr>
             <a:r>
-              <a:rPr sz="1200" b="0" i="0">
+              <a:rPr sz="1600" b="0" i="0">
                 <a:solidFill>
                   <a:srgbClr val="333333"/>
                 </a:solidFill>
@@ -5751,7 +6410,7 @@
               </a:spcAft>
             </a:pPr>
             <a:r>
-              <a:rPr sz="1400" b="1" i="0">
+              <a:rPr b="1" i="0">
                 <a:solidFill>
                   <a:srgbClr val="663399"/>
                 </a:solidFill>
@@ -5767,7 +6426,7 @@
               </a:spcAft>
             </a:pPr>
             <a:r>
-              <a:rPr sz="1200" b="0" i="0">
+              <a:rPr sz="1600" b="0" i="0">
                 <a:solidFill>
                   <a:srgbClr val="333333"/>
                 </a:solidFill>
@@ -5783,7 +6442,7 @@
               </a:spcAft>
             </a:pPr>
             <a:r>
-              <a:rPr sz="1200" b="0" i="0">
+              <a:rPr sz="1600" b="0" i="0">
                 <a:solidFill>
                   <a:srgbClr val="333333"/>
                 </a:solidFill>
@@ -5799,7 +6458,7 @@
               </a:spcAft>
             </a:pPr>
             <a:r>
-              <a:rPr sz="1200" b="0" i="0">
+              <a:rPr sz="1600" b="0" i="0">
                 <a:solidFill>
                   <a:srgbClr val="333333"/>
                 </a:solidFill>
@@ -5818,8 +6477,8 @@
 </p:sld>
 </file>
 
-<file path=ppt/slides/slide11.xml><?xml version="1.0" encoding="utf-8"?>
-<p:sld xmlns:a="http://schemas.openxmlformats.org/drawingml/2006/main" xmlns:p="http://schemas.openxmlformats.org/presentationml/2006/main" xmlns:r="http://schemas.openxmlformats.org/officeDocument/2006/relationships">
+<file path=ppt/slides/slide5.xml><?xml version="1.0" encoding="utf-8"?>
+<p:sld xmlns:a="http://schemas.openxmlformats.org/drawingml/2006/main" xmlns:r="http://schemas.openxmlformats.org/officeDocument/2006/relationships" xmlns:p="http://schemas.openxmlformats.org/presentationml/2006/main">
   <p:cSld>
     <p:spTree>
       <p:nvGrpSpPr>
@@ -5827,7 +6486,14 @@
         <p:cNvGrpSpPr/>
         <p:nvPr/>
       </p:nvGrpSpPr>
-      <p:grpSpPr/>
+      <p:grpSpPr>
+        <a:xfrm>
+          <a:off x="0" y="0"/>
+          <a:ext cx="0" cy="0"/>
+          <a:chOff x="0" y="0"/>
+          <a:chExt cx="0" cy="0"/>
+        </a:xfrm>
+      </p:grpSpPr>
       <p:sp>
         <p:nvSpPr>
           <p:cNvPr id="2" name="Title 1"/>
@@ -5844,10 +6510,7 @@
           <a:lstStyle/>
           <a:p>
             <a:r>
-              <a:rPr sz="3200" b="1">
-                <a:solidFill>
-                  <a:srgbClr val="CC0066"/>
-                </a:solidFill>
+              <a:rPr sz="3200" b="1" dirty="0">
                 <a:latin typeface="Calibri"/>
               </a:rPr>
               <a:t>When To Pick Which</a:t>
@@ -5864,7 +6527,7 @@
         <p:spPr>
           <a:xfrm>
             <a:off x="822960" y="1417320"/>
-            <a:ext cx="10515600" cy="365760"/>
+            <a:ext cx="10515600" cy="338554"/>
           </a:xfrm>
           <a:prstGeom prst="rect">
             <a:avLst/>
@@ -5872,14 +6535,14 @@
           <a:noFill/>
         </p:spPr>
         <p:txBody>
-          <a:bodyPr wrap="square" anchor="t" lIns="45720" rIns="45720">
+          <a:bodyPr wrap="square" lIns="45720" rIns="45720" anchor="t">
             <a:spAutoFit/>
           </a:bodyPr>
           <a:lstStyle/>
           <a:p>
             <a:pPr algn="l"/>
             <a:r>
-              <a:rPr sz="1500" b="0" i="1">
+              <a:rPr sz="1600" b="0" i="1" dirty="0">
                 <a:solidFill>
                   <a:srgbClr val="666666"/>
                 </a:solidFill>
@@ -5933,6 +6596,7 @@
           <a:lstStyle/>
           <a:p>
             <a:pPr algn="ctr"/>
+            <a:endParaRPr/>
           </a:p>
         </p:txBody>
       </p:sp>
@@ -5953,7 +6617,7 @@
           <a:noFill/>
         </p:spPr>
         <p:txBody>
-          <a:bodyPr wrap="square" anchor="t" lIns="45720" rIns="45720">
+          <a:bodyPr wrap="square" lIns="45720" rIns="45720" anchor="t">
             <a:spAutoFit/>
           </a:bodyPr>
           <a:lstStyle/>
@@ -5980,7 +6644,7 @@
         <p:spPr>
           <a:xfrm>
             <a:off x="960120" y="2468880"/>
-            <a:ext cx="4937760" cy="3794760"/>
+            <a:ext cx="4937760" cy="2446824"/>
           </a:xfrm>
           <a:prstGeom prst="rect">
             <a:avLst/>
@@ -5999,7 +6663,7 @@
               </a:spcAft>
             </a:pPr>
             <a:r>
-              <a:rPr sz="1300" b="0" i="0">
+              <a:rPr sz="1600" b="0" i="0" dirty="0">
                 <a:solidFill>
                   <a:srgbClr val="333333"/>
                 </a:solidFill>
@@ -6015,7 +6679,7 @@
               </a:spcAft>
             </a:pPr>
             <a:r>
-              <a:rPr sz="1300" b="0" i="0">
+              <a:rPr sz="1600" b="0" i="0" dirty="0">
                 <a:solidFill>
                   <a:srgbClr val="333333"/>
                 </a:solidFill>
@@ -6031,7 +6695,7 @@
               </a:spcAft>
             </a:pPr>
             <a:r>
-              <a:rPr sz="1300" b="0" i="0">
+              <a:rPr sz="1600" b="0" i="0" dirty="0">
                 <a:solidFill>
                   <a:srgbClr val="333333"/>
                 </a:solidFill>
@@ -6047,13 +6711,31 @@
               </a:spcAft>
             </a:pPr>
             <a:r>
-              <a:rPr sz="1300" b="0" i="0">
+              <a:rPr sz="1600" b="0" i="0" dirty="0">
                 <a:solidFill>
                   <a:srgbClr val="333333"/>
                 </a:solidFill>
                 <a:latin typeface="Calibri"/>
               </a:rPr>
-              <a:t>• Team has no Yocto experience and timeline is tight</a:t>
+              <a:t>• Team has no </a:t>
+            </a:r>
+            <a:r>
+              <a:rPr sz="1600" b="0" i="0" dirty="0" err="1">
+                <a:solidFill>
+                  <a:srgbClr val="333333"/>
+                </a:solidFill>
+                <a:latin typeface="Calibri"/>
+              </a:rPr>
+              <a:t>Yocto</a:t>
+            </a:r>
+            <a:r>
+              <a:rPr sz="1600" b="0" i="0" dirty="0">
+                <a:solidFill>
+                  <a:srgbClr val="333333"/>
+                </a:solidFill>
+                <a:latin typeface="Calibri"/>
+              </a:rPr>
+              <a:t> experience and timeline is tight</a:t>
             </a:r>
           </a:p>
           <a:p>
@@ -6063,7 +6745,7 @@
               </a:spcAft>
             </a:pPr>
             <a:r>
-              <a:rPr sz="1300" b="0" i="0">
+              <a:rPr sz="1600" b="0" i="0" dirty="0">
                 <a:solidFill>
                   <a:srgbClr val="333333"/>
                 </a:solidFill>
@@ -6079,7 +6761,7 @@
               </a:spcAft>
             </a:pPr>
             <a:r>
-              <a:rPr sz="1300" b="1" i="0">
+              <a:rPr sz="1600" b="1" i="0" dirty="0">
                 <a:solidFill>
                   <a:srgbClr val="CC0066"/>
                 </a:solidFill>
@@ -6095,7 +6777,7 @@
               </a:spcAft>
             </a:pPr>
             <a:r>
-              <a:rPr sz="1200" b="0" i="1">
+              <a:rPr sz="1600" b="0" i="1" dirty="0">
                 <a:solidFill>
                   <a:srgbClr val="333333"/>
                 </a:solidFill>
@@ -6149,6 +6831,7 @@
           <a:lstStyle/>
           <a:p>
             <a:pPr algn="ctr"/>
+            <a:endParaRPr/>
           </a:p>
         </p:txBody>
       </p:sp>
@@ -6169,7 +6852,7 @@
           <a:noFill/>
         </p:spPr>
         <p:txBody>
-          <a:bodyPr wrap="square" anchor="t" lIns="45720" rIns="45720">
+          <a:bodyPr wrap="square" lIns="45720" rIns="45720" anchor="t">
             <a:spAutoFit/>
           </a:bodyPr>
           <a:lstStyle/>
@@ -6196,7 +6879,7 @@
         <p:spPr>
           <a:xfrm>
             <a:off x="6400800" y="2468880"/>
-            <a:ext cx="4937760" cy="3794760"/>
+            <a:ext cx="4937760" cy="2446824"/>
           </a:xfrm>
           <a:prstGeom prst="rect">
             <a:avLst/>
@@ -6215,7 +6898,7 @@
               </a:spcAft>
             </a:pPr>
             <a:r>
-              <a:rPr sz="1300" b="0" i="0">
+              <a:rPr sz="1600" b="0" i="0">
                 <a:solidFill>
                   <a:srgbClr val="333333"/>
                 </a:solidFill>
@@ -6231,7 +6914,7 @@
               </a:spcAft>
             </a:pPr>
             <a:r>
-              <a:rPr sz="1300" b="0" i="0">
+              <a:rPr sz="1600" b="0" i="0">
                 <a:solidFill>
                   <a:srgbClr val="333333"/>
                 </a:solidFill>
@@ -6247,7 +6930,7 @@
               </a:spcAft>
             </a:pPr>
             <a:r>
-              <a:rPr sz="1300" b="0" i="0">
+              <a:rPr sz="1600" b="0" i="0">
                 <a:solidFill>
                   <a:srgbClr val="333333"/>
                 </a:solidFill>
@@ -6263,7 +6946,7 @@
               </a:spcAft>
             </a:pPr>
             <a:r>
-              <a:rPr sz="1300" b="0" i="0">
+              <a:rPr sz="1600" b="0" i="0">
                 <a:solidFill>
                   <a:srgbClr val="333333"/>
                 </a:solidFill>
@@ -6279,7 +6962,7 @@
               </a:spcAft>
             </a:pPr>
             <a:r>
-              <a:rPr sz="1300" b="0" i="0">
+              <a:rPr sz="1600" b="0" i="0">
                 <a:solidFill>
                   <a:srgbClr val="333333"/>
                 </a:solidFill>
@@ -6295,7 +6978,7 @@
               </a:spcAft>
             </a:pPr>
             <a:r>
-              <a:rPr sz="1300" b="1" i="0">
+              <a:rPr sz="1600" b="1" i="0">
                 <a:solidFill>
                   <a:srgbClr val="663399"/>
                 </a:solidFill>
@@ -6311,7 +6994,7 @@
               </a:spcAft>
             </a:pPr>
             <a:r>
-              <a:rPr sz="1200" b="0" i="1">
+              <a:rPr sz="1600" b="0" i="1">
                 <a:solidFill>
                   <a:srgbClr val="333333"/>
                 </a:solidFill>
@@ -6330,8 +7013,8 @@
 </p:sld>
 </file>
 
-<file path=ppt/slides/slide12.xml><?xml version="1.0" encoding="utf-8"?>
-<p:sld xmlns:a="http://schemas.openxmlformats.org/drawingml/2006/main" xmlns:p="http://schemas.openxmlformats.org/presentationml/2006/main" xmlns:r="http://schemas.openxmlformats.org/officeDocument/2006/relationships">
+<file path=ppt/slides/slide6.xml><?xml version="1.0" encoding="utf-8"?>
+<p:sld xmlns:a="http://schemas.openxmlformats.org/drawingml/2006/main" xmlns:r="http://schemas.openxmlformats.org/officeDocument/2006/relationships" xmlns:p="http://schemas.openxmlformats.org/presentationml/2006/main">
   <p:cSld>
     <p:spTree>
       <p:nvGrpSpPr>
@@ -6339,7 +7022,14 @@
         <p:cNvGrpSpPr/>
         <p:nvPr/>
       </p:nvGrpSpPr>
-      <p:grpSpPr/>
+      <p:grpSpPr>
+        <a:xfrm>
+          <a:off x="0" y="0"/>
+          <a:ext cx="0" cy="0"/>
+          <a:chOff x="0" y="0"/>
+          <a:chExt cx="0" cy="0"/>
+        </a:xfrm>
+      </p:grpSpPr>
       <p:sp>
         <p:nvSpPr>
           <p:cNvPr id="2" name="Title 1"/>
@@ -6356,10 +7046,7 @@
           <a:lstStyle/>
           <a:p>
             <a:r>
-              <a:rPr sz="3200" b="1">
-                <a:solidFill>
-                  <a:srgbClr val="CC0066"/>
-                </a:solidFill>
+              <a:rPr sz="3200" b="1" dirty="0">
                 <a:latin typeface="Calibri"/>
               </a:rPr>
               <a:t>Cross-Compilation Fundamentals</a:t>
@@ -6384,7 +7071,7 @@
           <a:noFill/>
         </p:spPr>
         <p:txBody>
-          <a:bodyPr wrap="square" anchor="t" lIns="45720" rIns="45720">
+          <a:bodyPr wrap="square" lIns="45720" rIns="45720" anchor="t">
             <a:spAutoFit/>
           </a:bodyPr>
           <a:lstStyle/>
@@ -6411,7 +7098,7 @@
         <p:spPr>
           <a:xfrm>
             <a:off x="822960" y="1783080"/>
-            <a:ext cx="10515600" cy="4480560"/>
+            <a:ext cx="10515600" cy="3005951"/>
           </a:xfrm>
           <a:prstGeom prst="rect">
             <a:avLst/>
@@ -6430,7 +7117,7 @@
               </a:spcAft>
             </a:pPr>
             <a:r>
-              <a:rPr sz="1600" b="1" i="0">
+              <a:rPr sz="2000" b="1" i="0" dirty="0">
                 <a:solidFill>
                   <a:srgbClr val="CC0066"/>
                 </a:solidFill>
@@ -6446,7 +7133,7 @@
               </a:spcAft>
             </a:pPr>
             <a:r>
-              <a:rPr sz="1300" b="0" i="0">
+              <a:rPr sz="1600" b="0" i="0" dirty="0">
                 <a:solidFill>
                   <a:srgbClr val="333333"/>
                 </a:solidFill>
@@ -6462,7 +7149,7 @@
               </a:spcAft>
             </a:pPr>
             <a:r>
-              <a:rPr sz="1300" b="0" i="0">
+              <a:rPr sz="1600" b="0" i="0" dirty="0">
                 <a:solidFill>
                   <a:srgbClr val="333333"/>
                 </a:solidFill>
@@ -6478,7 +7165,7 @@
               </a:spcAft>
             </a:pPr>
             <a:r>
-              <a:rPr sz="1600" b="1" i="0">
+              <a:rPr sz="2000" b="1" i="0" dirty="0">
                 <a:solidFill>
                   <a:srgbClr val="CC0066"/>
                 </a:solidFill>
@@ -6494,13 +7181,49 @@
               </a:spcAft>
             </a:pPr>
             <a:r>
-              <a:rPr sz="1300" b="0" i="0">
+              <a:rPr sz="1600" b="0" i="0" dirty="0">
                 <a:solidFill>
                   <a:srgbClr val="333333"/>
                 </a:solidFill>
                 <a:latin typeface="Calibri"/>
               </a:rPr>
-              <a:t>• Cross-compiler  (e.g., arm-linux-gnueabihf-gcc)</a:t>
+              <a:t>• Cross-compiler  (e.g., arm-</a:t>
+            </a:r>
+            <a:r>
+              <a:rPr sz="1600" b="0" i="0" dirty="0" err="1">
+                <a:solidFill>
+                  <a:srgbClr val="333333"/>
+                </a:solidFill>
+                <a:latin typeface="Calibri"/>
+              </a:rPr>
+              <a:t>linux</a:t>
+            </a:r>
+            <a:r>
+              <a:rPr sz="1600" b="0" i="0" dirty="0">
+                <a:solidFill>
+                  <a:srgbClr val="333333"/>
+                </a:solidFill>
+                <a:latin typeface="Calibri"/>
+              </a:rPr>
+              <a:t>-</a:t>
+            </a:r>
+            <a:r>
+              <a:rPr sz="1600" b="0" i="0" dirty="0" err="1">
+                <a:solidFill>
+                  <a:srgbClr val="333333"/>
+                </a:solidFill>
+                <a:latin typeface="Calibri"/>
+              </a:rPr>
+              <a:t>gnueabihf-gcc</a:t>
+            </a:r>
+            <a:r>
+              <a:rPr sz="1600" b="0" i="0" dirty="0">
+                <a:solidFill>
+                  <a:srgbClr val="333333"/>
+                </a:solidFill>
+                <a:latin typeface="Calibri"/>
+              </a:rPr>
+              <a:t>)</a:t>
             </a:r>
           </a:p>
           <a:p>
@@ -6510,13 +7233,67 @@
               </a:spcAft>
             </a:pPr>
             <a:r>
-              <a:rPr sz="1300" b="0" i="0">
+              <a:rPr sz="1600" b="0" i="0" dirty="0">
                 <a:solidFill>
                   <a:srgbClr val="333333"/>
                 </a:solidFill>
                 <a:latin typeface="Calibri"/>
               </a:rPr>
-              <a:t>• Cross-binutils  (as, ld, objdump for the target)</a:t>
+              <a:t>• Cross-</a:t>
+            </a:r>
+            <a:r>
+              <a:rPr sz="1600" b="0" i="0" dirty="0" err="1">
+                <a:solidFill>
+                  <a:srgbClr val="333333"/>
+                </a:solidFill>
+                <a:latin typeface="Calibri"/>
+              </a:rPr>
+              <a:t>binutils</a:t>
+            </a:r>
+            <a:r>
+              <a:rPr sz="1600" b="0" i="0" dirty="0">
+                <a:solidFill>
+                  <a:srgbClr val="333333"/>
+                </a:solidFill>
+                <a:latin typeface="Calibri"/>
+              </a:rPr>
+              <a:t>  (as, </a:t>
+            </a:r>
+            <a:r>
+              <a:rPr sz="1600" b="0" i="0" dirty="0" err="1">
+                <a:solidFill>
+                  <a:srgbClr val="333333"/>
+                </a:solidFill>
+                <a:latin typeface="Calibri"/>
+              </a:rPr>
+              <a:t>ld</a:t>
+            </a:r>
+            <a:r>
+              <a:rPr sz="1600" b="0" i="0" dirty="0">
+                <a:solidFill>
+                  <a:srgbClr val="333333"/>
+                </a:solidFill>
+                <a:latin typeface="Calibri"/>
+              </a:rPr>
+              <a:t>, </a:t>
+            </a:r>
+            <a:r>
+              <a:rPr sz="1600" b="0" i="0" dirty="0" err="1">
+                <a:solidFill>
+                  <a:srgbClr val="333333"/>
+                </a:solidFill>
+                <a:latin typeface="Calibri"/>
+              </a:rPr>
+              <a:t>objdump</a:t>
+            </a:r>
+            <a:r>
+              <a:rPr sz="1600" b="0" i="0" dirty="0">
+                <a:solidFill>
+                  <a:srgbClr val="333333"/>
+                </a:solidFill>
+                <a:latin typeface="Calibri"/>
+              </a:rPr>
+              <a:t> for the target)</a:t>
             </a:r>
           </a:p>
           <a:p>
@@ -6526,13 +7303,31 @@
               </a:spcAft>
             </a:pPr>
             <a:r>
-              <a:rPr sz="1300" b="0" i="0">
+              <a:rPr sz="1600" b="0" i="0" dirty="0">
                 <a:solidFill>
                   <a:srgbClr val="333333"/>
                 </a:solidFill>
                 <a:latin typeface="Calibri"/>
               </a:rPr>
-              <a:t>• Target sysroot — libraries and headers the target will use</a:t>
+              <a:t>• Target </a:t>
+            </a:r>
+            <a:r>
+              <a:rPr sz="1600" b="0" i="0" dirty="0" err="1">
+                <a:solidFill>
+                  <a:srgbClr val="333333"/>
+                </a:solidFill>
+                <a:latin typeface="Calibri"/>
+              </a:rPr>
+              <a:t>sysroot</a:t>
+            </a:r>
+            <a:r>
+              <a:rPr sz="1600" b="0" i="0" dirty="0">
+                <a:solidFill>
+                  <a:srgbClr val="333333"/>
+                </a:solidFill>
+                <a:latin typeface="Calibri"/>
+              </a:rPr>
+              <a:t> — libraries and headers the target will use</a:t>
             </a:r>
           </a:p>
           <a:p>
@@ -6542,13 +7337,22 @@
               </a:spcAft>
             </a:pPr>
             <a:r>
-              <a:rPr sz="1600" b="1" i="0">
+              <a:rPr sz="2000" b="1" i="0" dirty="0" err="1">
                 <a:solidFill>
                   <a:srgbClr val="663399"/>
                 </a:solidFill>
                 <a:latin typeface="Calibri"/>
               </a:rPr>
-              <a:t>Yocto generates the toolchain for you</a:t>
+              <a:t>Yocto</a:t>
+            </a:r>
+            <a:r>
+              <a:rPr sz="2000" b="1" i="0" dirty="0">
+                <a:solidFill>
+                  <a:srgbClr val="663399"/>
+                </a:solidFill>
+                <a:latin typeface="Calibri"/>
+              </a:rPr>
+              <a:t> generates the toolchain for you</a:t>
             </a:r>
           </a:p>
           <a:p>
@@ -6558,13 +7362,85 @@
               </a:spcAft>
             </a:pPr>
             <a:r>
-              <a:rPr sz="1300" b="0" i="0">
+              <a:rPr sz="1600" b="0" i="0" dirty="0">
                 <a:solidFill>
                   <a:srgbClr val="333333"/>
                 </a:solidFill>
                 <a:latin typeface="Calibri"/>
               </a:rPr>
-              <a:t>You don't install one separately. Yocto builds gcc + binutils + glibc against your target's spec, fresh every time it changes.</a:t>
+              <a:t>You don't install one separately. </a:t>
+            </a:r>
+            <a:r>
+              <a:rPr sz="1600" b="0" i="0" dirty="0" err="1">
+                <a:solidFill>
+                  <a:srgbClr val="333333"/>
+                </a:solidFill>
+                <a:latin typeface="Calibri"/>
+              </a:rPr>
+              <a:t>Yocto</a:t>
+            </a:r>
+            <a:r>
+              <a:rPr sz="1600" b="0" i="0" dirty="0">
+                <a:solidFill>
+                  <a:srgbClr val="333333"/>
+                </a:solidFill>
+                <a:latin typeface="Calibri"/>
+              </a:rPr>
+              <a:t> builds </a:t>
+            </a:r>
+            <a:r>
+              <a:rPr sz="1600" b="0" i="0" dirty="0" err="1">
+                <a:solidFill>
+                  <a:srgbClr val="333333"/>
+                </a:solidFill>
+                <a:latin typeface="Calibri"/>
+              </a:rPr>
+              <a:t>gcc</a:t>
+            </a:r>
+            <a:r>
+              <a:rPr sz="1600" b="0" i="0" dirty="0">
+                <a:solidFill>
+                  <a:srgbClr val="333333"/>
+                </a:solidFill>
+                <a:latin typeface="Calibri"/>
+              </a:rPr>
+              <a:t> + </a:t>
+            </a:r>
+            <a:r>
+              <a:rPr sz="1600" b="0" i="0" dirty="0" err="1">
+                <a:solidFill>
+                  <a:srgbClr val="333333"/>
+                </a:solidFill>
+                <a:latin typeface="Calibri"/>
+              </a:rPr>
+              <a:t>binutils</a:t>
+            </a:r>
+            <a:r>
+              <a:rPr sz="1600" b="0" i="0" dirty="0">
+                <a:solidFill>
+                  <a:srgbClr val="333333"/>
+                </a:solidFill>
+                <a:latin typeface="Calibri"/>
+              </a:rPr>
+              <a:t> + </a:t>
+            </a:r>
+            <a:r>
+              <a:rPr sz="1600" b="0" i="0" dirty="0" err="1">
+                <a:solidFill>
+                  <a:srgbClr val="333333"/>
+                </a:solidFill>
+                <a:latin typeface="Calibri"/>
+              </a:rPr>
+              <a:t>glibc</a:t>
+            </a:r>
+            <a:r>
+              <a:rPr sz="1600" b="0" i="0" dirty="0">
+                <a:solidFill>
+                  <a:srgbClr val="333333"/>
+                </a:solidFill>
+                <a:latin typeface="Calibri"/>
+              </a:rPr>
+              <a:t> against your target's spec, fresh every time it changes.</a:t>
             </a:r>
           </a:p>
         </p:txBody>
@@ -6577,8 +7453,8 @@
 </p:sld>
 </file>
 
-<file path=ppt/slides/slide13.xml><?xml version="1.0" encoding="utf-8"?>
-<p:sld xmlns:a="http://schemas.openxmlformats.org/drawingml/2006/main" xmlns:p="http://schemas.openxmlformats.org/presentationml/2006/main" xmlns:r="http://schemas.openxmlformats.org/officeDocument/2006/relationships">
+<file path=ppt/slides/slide7.xml><?xml version="1.0" encoding="utf-8"?>
+<p:sld xmlns:a="http://schemas.openxmlformats.org/drawingml/2006/main" xmlns:r="http://schemas.openxmlformats.org/officeDocument/2006/relationships" xmlns:p="http://schemas.openxmlformats.org/presentationml/2006/main">
   <p:cSld>
     <p:spTree>
       <p:nvGrpSpPr>
@@ -6586,7 +7462,14 @@
         <p:cNvGrpSpPr/>
         <p:nvPr/>
       </p:nvGrpSpPr>
-      <p:grpSpPr/>
+      <p:grpSpPr>
+        <a:xfrm>
+          <a:off x="0" y="0"/>
+          <a:ext cx="0" cy="0"/>
+          <a:chOff x="0" y="0"/>
+          <a:chExt cx="0" cy="0"/>
+        </a:xfrm>
+      </p:grpSpPr>
       <p:sp>
         <p:nvSpPr>
           <p:cNvPr id="2" name="Title 1"/>
@@ -6603,10 +7486,7 @@
           <a:lstStyle/>
           <a:p>
             <a:r>
-              <a:rPr sz="3200" b="1">
-                <a:solidFill>
-                  <a:srgbClr val="CC0066"/>
-                </a:solidFill>
+              <a:rPr sz="3200" b="1" dirty="0">
                 <a:latin typeface="Calibri"/>
               </a:rPr>
               <a:t>Triples and ABIs</a:t>
@@ -6623,7 +7503,7 @@
         <p:spPr>
           <a:xfrm>
             <a:off x="822960" y="1417320"/>
-            <a:ext cx="10515600" cy="365760"/>
+            <a:ext cx="10515600" cy="338554"/>
           </a:xfrm>
           <a:prstGeom prst="rect">
             <a:avLst/>
@@ -6631,14 +7511,14 @@
           <a:noFill/>
         </p:spPr>
         <p:txBody>
-          <a:bodyPr wrap="square" anchor="t" lIns="45720" rIns="45720">
+          <a:bodyPr wrap="square" lIns="45720" rIns="45720" anchor="t">
             <a:spAutoFit/>
           </a:bodyPr>
           <a:lstStyle/>
           <a:p>
             <a:pPr algn="l"/>
             <a:r>
-              <a:rPr sz="1500" b="0" i="1">
+              <a:rPr sz="1600" b="0" i="1">
                 <a:solidFill>
                   <a:srgbClr val="666666"/>
                 </a:solidFill>
@@ -6658,7 +7538,7 @@
         <p:spPr>
           <a:xfrm>
             <a:off x="822960" y="1783080"/>
-            <a:ext cx="10515600" cy="457200"/>
+            <a:ext cx="10515600" cy="338554"/>
           </a:xfrm>
           <a:prstGeom prst="rect">
             <a:avLst/>
@@ -6677,7 +7557,7 @@
               </a:spcAft>
             </a:pPr>
             <a:r>
-              <a:rPr sz="1500" b="1" i="0">
+              <a:rPr sz="1600" b="1" i="0">
                 <a:solidFill>
                   <a:srgbClr val="663399"/>
                 </a:solidFill>
@@ -6731,6 +7611,7 @@
           <a:lstStyle/>
           <a:p>
             <a:pPr algn="ctr"/>
+            <a:endParaRPr/>
           </a:p>
         </p:txBody>
       </p:sp>
@@ -6775,6 +7656,7 @@
           <a:lstStyle/>
           <a:p>
             <a:pPr algn="ctr"/>
+            <a:endParaRPr/>
           </a:p>
         </p:txBody>
       </p:sp>
@@ -6787,7 +7669,7 @@
         <p:spPr>
           <a:xfrm>
             <a:off x="1005840" y="2423160"/>
-            <a:ext cx="10241280" cy="3017520"/>
+            <a:ext cx="10241280" cy="3046988"/>
           </a:xfrm>
           <a:prstGeom prst="rect">
             <a:avLst/>
@@ -6806,7 +7688,7 @@
               </a:spcAft>
             </a:pPr>
             <a:r>
-              <a:rPr sz="1100" i="1">
+              <a:rPr sz="1600" i="1" dirty="0">
                 <a:solidFill>
                   <a:srgbClr val="808080"/>
                 </a:solidFill>
@@ -6814,6 +7696,12 @@
               </a:rPr>
               <a:t># Common triples</a:t>
             </a:r>
+            <a:endParaRPr sz="1600" dirty="0">
+              <a:solidFill>
+                <a:srgbClr val="2D2D2D"/>
+              </a:solidFill>
+              <a:latin typeface="Consolas"/>
+            </a:endParaRPr>
           </a:p>
           <a:p>
             <a:pPr>
@@ -6822,13 +7710,13 @@
               </a:spcAft>
             </a:pPr>
             <a:r>
-              <a:rPr sz="1100">
+              <a:rPr sz="1600" dirty="0">
                 <a:solidFill>
                   <a:srgbClr val="2D2D2D"/>
                 </a:solidFill>
                 <a:latin typeface="Consolas"/>
               </a:rPr>
-              <a:t> </a:t>
+              <a:t>x86_64-linux-gnu              # 64-bit x86 desktop</a:t>
             </a:r>
           </a:p>
           <a:p>
@@ -6838,13 +7726,13 @@
               </a:spcAft>
             </a:pPr>
             <a:r>
-              <a:rPr sz="1100">
+              <a:rPr sz="1600" dirty="0">
                 <a:solidFill>
                   <a:srgbClr val="2D2D2D"/>
                 </a:solidFill>
                 <a:latin typeface="Consolas"/>
               </a:rPr>
-              <a:t>x86_64-linux-gnu              # 64-bit x86 desktop</a:t>
+              <a:t>aarch64-linux-gnu             # 64-bit ARM (most modern SoCs)</a:t>
             </a:r>
           </a:p>
           <a:p>
@@ -6854,13 +7742,49 @@
               </a:spcAft>
             </a:pPr>
             <a:r>
-              <a:rPr sz="1100">
+              <a:rPr sz="1600" dirty="0">
                 <a:solidFill>
                   <a:srgbClr val="2D2D2D"/>
                 </a:solidFill>
                 <a:latin typeface="Consolas"/>
               </a:rPr>
-              <a:t>aarch64-linux-gnu             # 64-bit ARM (most modern SoCs)</a:t>
+              <a:t>arm-</a:t>
+            </a:r>
+            <a:r>
+              <a:rPr sz="1600" dirty="0" err="1">
+                <a:solidFill>
+                  <a:srgbClr val="2D2D2D"/>
+                </a:solidFill>
+                <a:latin typeface="Consolas"/>
+              </a:rPr>
+              <a:t>linux</a:t>
+            </a:r>
+            <a:r>
+              <a:rPr sz="1600" dirty="0">
+                <a:solidFill>
+                  <a:srgbClr val="2D2D2D"/>
+                </a:solidFill>
+                <a:latin typeface="Consolas"/>
+              </a:rPr>
+              <a:t>-</a:t>
+            </a:r>
+            <a:r>
+              <a:rPr sz="1600" dirty="0" err="1">
+                <a:solidFill>
+                  <a:srgbClr val="2D2D2D"/>
+                </a:solidFill>
+                <a:latin typeface="Consolas"/>
+              </a:rPr>
+              <a:t>gnueabi</a:t>
+            </a:r>
+            <a:r>
+              <a:rPr sz="1600" dirty="0">
+                <a:solidFill>
+                  <a:srgbClr val="2D2D2D"/>
+                </a:solidFill>
+                <a:latin typeface="Consolas"/>
+              </a:rPr>
+              <a:t>             # 32-bit ARM, soft-float ABI</a:t>
             </a:r>
           </a:p>
           <a:p>
@@ -6870,13 +7794,49 @@
               </a:spcAft>
             </a:pPr>
             <a:r>
-              <a:rPr sz="1100">
+              <a:rPr sz="1600" dirty="0">
                 <a:solidFill>
                   <a:srgbClr val="2D2D2D"/>
                 </a:solidFill>
                 <a:latin typeface="Consolas"/>
               </a:rPr>
-              <a:t>arm-linux-gnueabi             # 32-bit ARM, soft-float ABI</a:t>
+              <a:t>arm-</a:t>
+            </a:r>
+            <a:r>
+              <a:rPr sz="1600" dirty="0" err="1">
+                <a:solidFill>
+                  <a:srgbClr val="2D2D2D"/>
+                </a:solidFill>
+                <a:latin typeface="Consolas"/>
+              </a:rPr>
+              <a:t>linux</a:t>
+            </a:r>
+            <a:r>
+              <a:rPr sz="1600" dirty="0">
+                <a:solidFill>
+                  <a:srgbClr val="2D2D2D"/>
+                </a:solidFill>
+                <a:latin typeface="Consolas"/>
+              </a:rPr>
+              <a:t>-</a:t>
+            </a:r>
+            <a:r>
+              <a:rPr sz="1600" dirty="0" err="1">
+                <a:solidFill>
+                  <a:srgbClr val="2D2D2D"/>
+                </a:solidFill>
+                <a:latin typeface="Consolas"/>
+              </a:rPr>
+              <a:t>gnueabihf</a:t>
+            </a:r>
+            <a:r>
+              <a:rPr sz="1600" dirty="0">
+                <a:solidFill>
+                  <a:srgbClr val="2D2D2D"/>
+                </a:solidFill>
+                <a:latin typeface="Consolas"/>
+              </a:rPr>
+              <a:t>           # 32-bit ARM, hard-float ABI</a:t>
             </a:r>
           </a:p>
           <a:p>
@@ -6886,13 +7846,49 @@
               </a:spcAft>
             </a:pPr>
             <a:r>
-              <a:rPr sz="1100">
+              <a:rPr sz="1600" dirty="0">
                 <a:solidFill>
                   <a:srgbClr val="2D2D2D"/>
                 </a:solidFill>
                 <a:latin typeface="Consolas"/>
               </a:rPr>
-              <a:t>arm-linux-gnueabihf           # 32-bit ARM, hard-float ABI</a:t>
+              <a:t>armv7-linux-musleabihf        # 32-bit ARMv7, </a:t>
+            </a:r>
+            <a:r>
+              <a:rPr sz="1600" dirty="0" err="1">
+                <a:solidFill>
+                  <a:srgbClr val="2D2D2D"/>
+                </a:solidFill>
+                <a:latin typeface="Consolas"/>
+              </a:rPr>
+              <a:t>musl</a:t>
+            </a:r>
+            <a:r>
+              <a:rPr sz="1600" dirty="0">
+                <a:solidFill>
+                  <a:srgbClr val="2D2D2D"/>
+                </a:solidFill>
+                <a:latin typeface="Consolas"/>
+              </a:rPr>
+              <a:t> </a:t>
+            </a:r>
+            <a:r>
+              <a:rPr sz="1600" dirty="0" err="1">
+                <a:solidFill>
+                  <a:srgbClr val="2D2D2D"/>
+                </a:solidFill>
+                <a:latin typeface="Consolas"/>
+              </a:rPr>
+              <a:t>libc</a:t>
+            </a:r>
+            <a:r>
+              <a:rPr sz="1600" dirty="0">
+                <a:solidFill>
+                  <a:srgbClr val="2D2D2D"/>
+                </a:solidFill>
+                <a:latin typeface="Consolas"/>
+              </a:rPr>
+              <a:t>, hard-float</a:t>
             </a:r>
           </a:p>
           <a:p>
@@ -6902,13 +7898,13 @@
               </a:spcAft>
             </a:pPr>
             <a:r>
-              <a:rPr sz="1100">
+              <a:rPr sz="1600" dirty="0">
                 <a:solidFill>
                   <a:srgbClr val="2D2D2D"/>
                 </a:solidFill>
                 <a:latin typeface="Consolas"/>
               </a:rPr>
-              <a:t>armv7-linux-musleabihf        # 32-bit ARMv7, musl libc, hard-float</a:t>
+              <a:t> </a:t>
             </a:r>
           </a:p>
           <a:p>
@@ -6918,13 +7914,13 @@
               </a:spcAft>
             </a:pPr>
             <a:r>
-              <a:rPr sz="1100">
-                <a:solidFill>
-                  <a:srgbClr val="2D2D2D"/>
+              <a:rPr sz="1600" i="1" dirty="0">
+                <a:solidFill>
+                  <a:srgbClr val="808080"/>
                 </a:solidFill>
                 <a:latin typeface="Consolas"/>
               </a:rPr>
-              <a:t> </a:t>
+              <a:t># What the parts mean</a:t>
             </a:r>
           </a:p>
           <a:p>
@@ -6934,13 +7930,13 @@
               </a:spcAft>
             </a:pPr>
             <a:r>
-              <a:rPr sz="1100" i="1">
+              <a:rPr sz="1600" i="1" dirty="0">
                 <a:solidFill>
                   <a:srgbClr val="808080"/>
                 </a:solidFill>
                 <a:latin typeface="Consolas"/>
               </a:rPr>
-              <a:t># What the parts mean</a:t>
+              <a:t>#   arch    = CPU family + sometimes version (armv7, aarch64)</a:t>
             </a:r>
           </a:p>
           <a:p>
@@ -6950,13 +7946,31 @@
               </a:spcAft>
             </a:pPr>
             <a:r>
-              <a:rPr sz="1100" i="1">
+              <a:rPr sz="1600" i="1" dirty="0">
                 <a:solidFill>
                   <a:srgbClr val="808080"/>
                 </a:solidFill>
                 <a:latin typeface="Consolas"/>
               </a:rPr>
-              <a:t>#   arch    = CPU family + sometimes version (armv7, aarch64)</a:t>
+              <a:t>#   vendor  = often omitted or '</a:t>
+            </a:r>
+            <a:r>
+              <a:rPr sz="1600" i="1" dirty="0" err="1">
+                <a:solidFill>
+                  <a:srgbClr val="808080"/>
+                </a:solidFill>
+                <a:latin typeface="Consolas"/>
+              </a:rPr>
+              <a:t>linux</a:t>
+            </a:r>
+            <a:r>
+              <a:rPr sz="1600" i="1" dirty="0">
+                <a:solidFill>
+                  <a:srgbClr val="808080"/>
+                </a:solidFill>
+                <a:latin typeface="Consolas"/>
+              </a:rPr>
+              <a:t>'</a:t>
             </a:r>
           </a:p>
           <a:p>
@@ -6966,13 +7980,49 @@
               </a:spcAft>
             </a:pPr>
             <a:r>
-              <a:rPr sz="1100" i="1">
+              <a:rPr sz="1600" i="1" dirty="0">
                 <a:solidFill>
                   <a:srgbClr val="808080"/>
                 </a:solidFill>
                 <a:latin typeface="Consolas"/>
               </a:rPr>
-              <a:t>#   vendor  = often omitted or 'linux'</a:t>
+              <a:t>#   </a:t>
+            </a:r>
+            <a:r>
+              <a:rPr sz="1600" i="1" dirty="0" err="1">
+                <a:solidFill>
+                  <a:srgbClr val="808080"/>
+                </a:solidFill>
+                <a:latin typeface="Consolas"/>
+              </a:rPr>
+              <a:t>os</a:t>
+            </a:r>
+            <a:r>
+              <a:rPr sz="1600" i="1" dirty="0">
+                <a:solidFill>
+                  <a:srgbClr val="808080"/>
+                </a:solidFill>
+                <a:latin typeface="Consolas"/>
+              </a:rPr>
+              <a:t>      = </a:t>
+            </a:r>
+            <a:r>
+              <a:rPr sz="1600" i="1" dirty="0" err="1">
+                <a:solidFill>
+                  <a:srgbClr val="808080"/>
+                </a:solidFill>
+                <a:latin typeface="Consolas"/>
+              </a:rPr>
+              <a:t>linux</a:t>
+            </a:r>
+            <a:r>
+              <a:rPr sz="1600" i="1" dirty="0">
+                <a:solidFill>
+                  <a:srgbClr val="808080"/>
+                </a:solidFill>
+                <a:latin typeface="Consolas"/>
+              </a:rPr>
+              <a:t>, none, mingw32, ...</a:t>
             </a:r>
           </a:p>
           <a:p>
@@ -6982,29 +8032,85 @@
               </a:spcAft>
             </a:pPr>
             <a:r>
-              <a:rPr sz="1100" i="1">
+              <a:rPr sz="1600" i="1" dirty="0">
                 <a:solidFill>
                   <a:srgbClr val="808080"/>
                 </a:solidFill>
                 <a:latin typeface="Consolas"/>
               </a:rPr>
-              <a:t>#   os      = linux, none, mingw32, ...</a:t>
-            </a:r>
-          </a:p>
-          <a:p>
-            <a:pPr>
-              <a:spcAft>
-                <a:spcPts val="0"/>
-              </a:spcAft>
-            </a:pPr>
-            <a:r>
-              <a:rPr sz="1100" i="1">
+              <a:t>#   </a:t>
+            </a:r>
+            <a:r>
+              <a:rPr sz="1600" i="1" dirty="0" err="1">
                 <a:solidFill>
                   <a:srgbClr val="808080"/>
                 </a:solidFill>
                 <a:latin typeface="Consolas"/>
               </a:rPr>
-              <a:t>#   abi     = gnu (glibc), gnueabihf, musl, ...</a:t>
+              <a:t>abi</a:t>
+            </a:r>
+            <a:r>
+              <a:rPr sz="1600" i="1" dirty="0">
+                <a:solidFill>
+                  <a:srgbClr val="808080"/>
+                </a:solidFill>
+                <a:latin typeface="Consolas"/>
+              </a:rPr>
+              <a:t>     = gnu (</a:t>
+            </a:r>
+            <a:r>
+              <a:rPr sz="1600" i="1" dirty="0" err="1">
+                <a:solidFill>
+                  <a:srgbClr val="808080"/>
+                </a:solidFill>
+                <a:latin typeface="Consolas"/>
+              </a:rPr>
+              <a:t>glibc</a:t>
+            </a:r>
+            <a:r>
+              <a:rPr sz="1600" i="1" dirty="0">
+                <a:solidFill>
+                  <a:srgbClr val="808080"/>
+                </a:solidFill>
+                <a:latin typeface="Consolas"/>
+              </a:rPr>
+              <a:t>), </a:t>
+            </a:r>
+            <a:r>
+              <a:rPr sz="1600" i="1" dirty="0" err="1">
+                <a:solidFill>
+                  <a:srgbClr val="808080"/>
+                </a:solidFill>
+                <a:latin typeface="Consolas"/>
+              </a:rPr>
+              <a:t>gnueabihf</a:t>
+            </a:r>
+            <a:r>
+              <a:rPr sz="1600" i="1" dirty="0">
+                <a:solidFill>
+                  <a:srgbClr val="808080"/>
+                </a:solidFill>
+                <a:latin typeface="Consolas"/>
+              </a:rPr>
+              <a:t>, </a:t>
+            </a:r>
+            <a:r>
+              <a:rPr sz="1600" i="1" dirty="0" err="1">
+                <a:solidFill>
+                  <a:srgbClr val="808080"/>
+                </a:solidFill>
+                <a:latin typeface="Consolas"/>
+              </a:rPr>
+              <a:t>musl</a:t>
+            </a:r>
+            <a:r>
+              <a:rPr sz="1600" i="1" dirty="0">
+                <a:solidFill>
+                  <a:srgbClr val="808080"/>
+                </a:solidFill>
+                <a:latin typeface="Consolas"/>
+              </a:rPr>
+              <a:t>, ...</a:t>
             </a:r>
           </a:p>
         </p:txBody>
@@ -7046,18 +8152,36 @@
           </a:fontRef>
         </p:style>
         <p:txBody>
-          <a:bodyPr rtlCol="0" anchor="ctr" lIns="228600" rIns="228600" wrap="square"/>
+          <a:bodyPr wrap="square" lIns="228600" rIns="228600" rtlCol="0" anchor="ctr"/>
           <a:lstStyle/>
           <a:p>
             <a:pPr algn="l"/>
             <a:r>
-              <a:rPr sz="1300" b="1">
+              <a:rPr sz="1600" b="1" dirty="0">
                 <a:solidFill>
                   <a:srgbClr val="663399"/>
                 </a:solidFill>
                 <a:latin typeface="Calibri"/>
               </a:rPr>
-              <a:t>Mixing ABIs is the #1 source of weird linker errors. armv7-eabi binaries don't run on eabihf systems and vice versa.</a:t>
+              <a:t>Mixing ABIs is the #1 source of weird linker errors. armv7-eabi binaries don't run on </a:t>
+            </a:r>
+            <a:r>
+              <a:rPr sz="1600" b="1" dirty="0" err="1">
+                <a:solidFill>
+                  <a:srgbClr val="663399"/>
+                </a:solidFill>
+                <a:latin typeface="Calibri"/>
+              </a:rPr>
+              <a:t>eabihf</a:t>
+            </a:r>
+            <a:r>
+              <a:rPr sz="1600" b="1" dirty="0">
+                <a:solidFill>
+                  <a:srgbClr val="663399"/>
+                </a:solidFill>
+                <a:latin typeface="Calibri"/>
+              </a:rPr>
+              <a:t> systems and vice versa.</a:t>
             </a:r>
           </a:p>
         </p:txBody>
@@ -7070,8 +8194,8 @@
 </p:sld>
 </file>
 
-<file path=ppt/slides/slide14.xml><?xml version="1.0" encoding="utf-8"?>
-<p:sld xmlns:a="http://schemas.openxmlformats.org/drawingml/2006/main" xmlns:p="http://schemas.openxmlformats.org/presentationml/2006/main" xmlns:r="http://schemas.openxmlformats.org/officeDocument/2006/relationships">
+<file path=ppt/slides/slide8.xml><?xml version="1.0" encoding="utf-8"?>
+<p:sld xmlns:a="http://schemas.openxmlformats.org/drawingml/2006/main" xmlns:r="http://schemas.openxmlformats.org/officeDocument/2006/relationships" xmlns:p="http://schemas.openxmlformats.org/presentationml/2006/main">
   <p:cSld>
     <p:spTree>
       <p:nvGrpSpPr>
@@ -7079,7 +8203,14 @@
         <p:cNvGrpSpPr/>
         <p:nvPr/>
       </p:nvGrpSpPr>
-      <p:grpSpPr/>
+      <p:grpSpPr>
+        <a:xfrm>
+          <a:off x="0" y="0"/>
+          <a:ext cx="0" cy="0"/>
+          <a:chOff x="0" y="0"/>
+          <a:chExt cx="0" cy="0"/>
+        </a:xfrm>
+      </p:grpSpPr>
       <p:sp>
         <p:nvSpPr>
           <p:cNvPr id="2" name="Title 1"/>
@@ -7096,10 +8227,7 @@
           <a:lstStyle/>
           <a:p>
             <a:r>
-              <a:rPr sz="3200" b="1">
-                <a:solidFill>
-                  <a:srgbClr val="663399"/>
-                </a:solidFill>
+              <a:rPr sz="3200" b="1" dirty="0">
                 <a:latin typeface="Calibri"/>
               </a:rPr>
               <a:t>Session Summary</a:t>
@@ -7124,7 +8252,7 @@
           <a:noFill/>
         </p:spPr>
         <p:txBody>
-          <a:bodyPr wrap="square" anchor="t" lIns="45720" rIns="45720">
+          <a:bodyPr wrap="square" lIns="45720" rIns="45720" anchor="t">
             <a:spAutoFit/>
           </a:bodyPr>
           <a:lstStyle/>
@@ -7179,7 +8307,7 @@
           </a:fontRef>
         </p:style>
         <p:txBody>
-          <a:bodyPr rtlCol="0" anchor="ctr" lIns="0" rIns="0"/>
+          <a:bodyPr lIns="0" rIns="0" rtlCol="0" anchor="ctr"/>
           <a:lstStyle/>
           <a:p>
             <a:pPr algn="ctr"/>
@@ -7212,7 +8340,7 @@
           <a:noFill/>
         </p:spPr>
         <p:txBody>
-          <a:bodyPr wrap="square" anchor="t" lIns="45720" rIns="45720">
+          <a:bodyPr wrap="square" lIns="45720" rIns="45720" anchor="t">
             <a:spAutoFit/>
           </a:bodyPr>
           <a:lstStyle/>
@@ -7247,7 +8375,7 @@
           <a:noFill/>
         </p:spPr>
         <p:txBody>
-          <a:bodyPr wrap="square" anchor="t" lIns="45720" rIns="45720">
+          <a:bodyPr wrap="square" lIns="45720" rIns="45720" anchor="t">
             <a:spAutoFit/>
           </a:bodyPr>
           <a:lstStyle/>
@@ -7302,7 +8430,7 @@
           </a:fontRef>
         </p:style>
         <p:txBody>
-          <a:bodyPr rtlCol="0" anchor="ctr" lIns="0" rIns="0"/>
+          <a:bodyPr lIns="0" rIns="0" rtlCol="0" anchor="ctr"/>
           <a:lstStyle/>
           <a:p>
             <a:pPr algn="ctr"/>
@@ -7335,7 +8463,7 @@
           <a:noFill/>
         </p:spPr>
         <p:txBody>
-          <a:bodyPr wrap="square" anchor="t" lIns="45720" rIns="45720">
+          <a:bodyPr wrap="square" lIns="45720" rIns="45720" anchor="t">
             <a:spAutoFit/>
           </a:bodyPr>
           <a:lstStyle/>
@@ -7370,7 +8498,7 @@
           <a:noFill/>
         </p:spPr>
         <p:txBody>
-          <a:bodyPr wrap="square" anchor="t" lIns="45720" rIns="45720">
+          <a:bodyPr wrap="square" lIns="45720" rIns="45720" anchor="t">
             <a:spAutoFit/>
           </a:bodyPr>
           <a:lstStyle/>
@@ -7425,7 +8553,7 @@
           </a:fontRef>
         </p:style>
         <p:txBody>
-          <a:bodyPr rtlCol="0" anchor="ctr" lIns="0" rIns="0"/>
+          <a:bodyPr lIns="0" rIns="0" rtlCol="0" anchor="ctr"/>
           <a:lstStyle/>
           <a:p>
             <a:pPr algn="ctr"/>
@@ -7458,7 +8586,7 @@
           <a:noFill/>
         </p:spPr>
         <p:txBody>
-          <a:bodyPr wrap="square" anchor="t" lIns="45720" rIns="45720">
+          <a:bodyPr wrap="square" lIns="45720" rIns="45720" anchor="t">
             <a:spAutoFit/>
           </a:bodyPr>
           <a:lstStyle/>
@@ -7493,7 +8621,7 @@
           <a:noFill/>
         </p:spPr>
         <p:txBody>
-          <a:bodyPr wrap="square" anchor="t" lIns="45720" rIns="45720">
+          <a:bodyPr wrap="square" lIns="45720" rIns="45720" anchor="t">
             <a:spAutoFit/>
           </a:bodyPr>
           <a:lstStyle/>
@@ -7548,7 +8676,7 @@
           </a:fontRef>
         </p:style>
         <p:txBody>
-          <a:bodyPr rtlCol="0" anchor="ctr" lIns="0" rIns="0"/>
+          <a:bodyPr lIns="0" rIns="0" rtlCol="0" anchor="ctr"/>
           <a:lstStyle/>
           <a:p>
             <a:pPr algn="ctr"/>
@@ -7581,7 +8709,7 @@
           <a:noFill/>
         </p:spPr>
         <p:txBody>
-          <a:bodyPr wrap="square" anchor="t" lIns="45720" rIns="45720">
+          <a:bodyPr wrap="square" lIns="45720" rIns="45720" anchor="t">
             <a:spAutoFit/>
           </a:bodyPr>
           <a:lstStyle/>
@@ -7616,7 +8744,7 @@
           <a:noFill/>
         </p:spPr>
         <p:txBody>
-          <a:bodyPr wrap="square" anchor="t" lIns="45720" rIns="45720">
+          <a:bodyPr wrap="square" lIns="45720" rIns="45720" anchor="t">
             <a:spAutoFit/>
           </a:bodyPr>
           <a:lstStyle/>
@@ -7671,7 +8799,7 @@
           </a:fontRef>
         </p:style>
         <p:txBody>
-          <a:bodyPr rtlCol="0" anchor="ctr" lIns="0" rIns="0"/>
+          <a:bodyPr lIns="0" rIns="0" rtlCol="0" anchor="ctr"/>
           <a:lstStyle/>
           <a:p>
             <a:pPr algn="ctr"/>
@@ -7704,7 +8832,7 @@
           <a:noFill/>
         </p:spPr>
         <p:txBody>
-          <a:bodyPr wrap="square" anchor="t" lIns="45720" rIns="45720">
+          <a:bodyPr wrap="square" lIns="45720" rIns="45720" anchor="t">
             <a:spAutoFit/>
           </a:bodyPr>
           <a:lstStyle/>
@@ -7739,7 +8867,7 @@
           <a:noFill/>
         </p:spPr>
         <p:txBody>
-          <a:bodyPr wrap="square" anchor="t" lIns="45720" rIns="45720">
+          <a:bodyPr wrap="square" lIns="45720" rIns="45720" anchor="t">
             <a:spAutoFit/>
           </a:bodyPr>
           <a:lstStyle/>
@@ -7794,12 +8922,12 @@
           </a:fontRef>
         </p:style>
         <p:txBody>
-          <a:bodyPr rtlCol="0" anchor="ctr" lIns="228600"/>
+          <a:bodyPr lIns="228600" rtlCol="0" anchor="ctr"/>
           <a:lstStyle/>
           <a:p>
             <a:pPr algn="ctr"/>
             <a:r>
-              <a:rPr sz="1400" b="1">
+              <a:rPr sz="1600" b="1" dirty="0">
                 <a:solidFill>
                   <a:srgbClr val="663399"/>
                 </a:solidFill>
@@ -7808,540 +8936,56 @@
               <a:t>Next session  →  </a:t>
             </a:r>
             <a:r>
-              <a:rPr sz="1400">
+              <a:rPr sz="1600" dirty="0" err="1">
                 <a:solidFill>
                   <a:srgbClr val="333333"/>
                 </a:solidFill>
                 <a:latin typeface="Calibri"/>
               </a:rPr>
-              <a:t>Yocto Architecture (75 min) — Poky, BitBake, recipes, layers, sstate</a:t>
-            </a:r>
-          </a:p>
-        </p:txBody>
-      </p:sp>
-    </p:spTree>
-  </p:cSld>
-  <p:clrMapOvr>
-    <a:masterClrMapping/>
-  </p:clrMapOvr>
-</p:sld>
-</file>
-
-<file path=ppt/slides/slide7.xml><?xml version="1.0" encoding="utf-8"?>
-<p:sld xmlns:a="http://schemas.openxmlformats.org/drawingml/2006/main" xmlns:p="http://schemas.openxmlformats.org/presentationml/2006/main" xmlns:r="http://schemas.openxmlformats.org/officeDocument/2006/relationships">
-  <p:cSld>
-    <p:spTree>
-      <p:nvGrpSpPr>
-        <p:cNvPr id="1" name=""/>
-        <p:cNvGrpSpPr/>
-        <p:nvPr/>
-      </p:nvGrpSpPr>
-      <p:grpSpPr/>
-      <p:sp>
-        <p:nvSpPr>
-          <p:cNvPr id="2" name="Title 1"/>
-          <p:cNvSpPr>
-            <a:spLocks noGrp="1"/>
-          </p:cNvSpPr>
-          <p:nvPr>
-            <p:ph type="ctrTitle"/>
-          </p:nvPr>
-        </p:nvSpPr>
-        <p:spPr/>
-        <p:txBody>
-          <a:bodyPr/>
-          <a:lstStyle/>
-          <a:p>
-            <a:r>
-              <a:rPr sz="4400" b="1">
-                <a:solidFill>
-                  <a:srgbClr val="FFFFFF"/>
-                </a:solidFill>
-                <a:latin typeface="Calibri"/>
-              </a:rPr>
-              <a:t>Embedded Linux Landscape</a:t>
-            </a:r>
-          </a:p>
-        </p:txBody>
-      </p:sp>
-      <p:sp>
-        <p:nvSpPr>
-          <p:cNvPr id="3" name="Subtitle 2"/>
-          <p:cNvSpPr>
-            <a:spLocks noGrp="1"/>
-          </p:cNvSpPr>
-          <p:nvPr>
-            <p:ph type="subTitle" idx="1"/>
-          </p:nvPr>
-        </p:nvSpPr>
-        <p:spPr/>
-        <p:txBody>
-          <a:bodyPr/>
-          <a:lstStyle/>
-          <a:p>
-            <a:r>
-              <a:rPr sz="2200" i="1">
-                <a:solidFill>
-                  <a:srgbClr val="FFFFFF"/>
-                </a:solidFill>
-                <a:latin typeface="Calibri"/>
-              </a:rPr>
-              <a:t>Day 1 • Session 4 • 30 minutes</a:t>
-            </a:r>
-          </a:p>
-          <a:p>
-            <a:r>
-              <a:rPr sz="1800">
-                <a:solidFill>
-                  <a:srgbClr val="FFFFFF"/>
-                </a:solidFill>
-                <a:latin typeface="Calibri"/>
-              </a:rPr>
-              <a:t>Where Yocto fits in the ecosystem</a:t>
-            </a:r>
-          </a:p>
-        </p:txBody>
-      </p:sp>
-    </p:spTree>
-  </p:cSld>
-  <p:clrMapOvr>
-    <a:masterClrMapping/>
-  </p:clrMapOvr>
-</p:sld>
-</file>
-
-<file path=ppt/slides/slide8.xml><?xml version="1.0" encoding="utf-8"?>
-<p:sld xmlns:a="http://schemas.openxmlformats.org/drawingml/2006/main" xmlns:p="http://schemas.openxmlformats.org/presentationml/2006/main" xmlns:r="http://schemas.openxmlformats.org/officeDocument/2006/relationships">
-  <p:cSld>
-    <p:spTree>
-      <p:nvGrpSpPr>
-        <p:cNvPr id="1" name=""/>
-        <p:cNvGrpSpPr/>
-        <p:nvPr/>
-      </p:nvGrpSpPr>
-      <p:grpSpPr/>
-      <p:sp>
-        <p:nvSpPr>
-          <p:cNvPr id="2" name="Title 1"/>
-          <p:cNvSpPr>
-            <a:spLocks noGrp="1"/>
-          </p:cNvSpPr>
-          <p:nvPr>
-            <p:ph type="title"/>
-          </p:nvPr>
-        </p:nvSpPr>
-        <p:spPr/>
-        <p:txBody>
-          <a:bodyPr/>
-          <a:lstStyle/>
-          <a:p>
-            <a:r>
-              <a:rPr sz="3200" b="1">
-                <a:solidFill>
-                  <a:srgbClr val="CC0066"/>
-                </a:solidFill>
-                <a:latin typeface="Calibri"/>
-              </a:rPr>
-              <a:t>Session Agenda</a:t>
-            </a:r>
-          </a:p>
-        </p:txBody>
-      </p:sp>
-      <p:sp>
-        <p:nvSpPr>
-          <p:cNvPr id="3" name="TextBox 2"/>
-          <p:cNvSpPr txBox="1"/>
-          <p:nvPr/>
-        </p:nvSpPr>
-        <p:spPr>
-          <a:xfrm>
-            <a:off x="822960" y="1463040"/>
-            <a:ext cx="10515600" cy="5029200"/>
-          </a:xfrm>
-          <a:prstGeom prst="rect">
-            <a:avLst/>
-          </a:prstGeom>
-          <a:noFill/>
-        </p:spPr>
-        <p:txBody>
-          <a:bodyPr wrap="square" lIns="45720" rIns="45720">
-            <a:spAutoFit/>
-          </a:bodyPr>
-          <a:lstStyle/>
-          <a:p>
-            <a:pPr>
-              <a:spcAft>
-                <a:spcPts val="600"/>
-              </a:spcAft>
-            </a:pPr>
-            <a:r>
-              <a:rPr sz="2000" b="0" i="0">
+              <a:t>Yocto</a:t>
+            </a:r>
+            <a:r>
+              <a:rPr sz="1600" dirty="0">
                 <a:solidFill>
                   <a:srgbClr val="333333"/>
                 </a:solidFill>
                 <a:latin typeface="Calibri"/>
               </a:rPr>
-              <a:t>1.  The embedded Linux problem</a:t>
-            </a:r>
-          </a:p>
-          <a:p>
-            <a:pPr>
-              <a:spcAft>
-                <a:spcPts val="600"/>
-              </a:spcAft>
-            </a:pPr>
-            <a:r>
-              <a:rPr sz="2000" b="0" i="0">
+              <a:t> Architecture — Poky, </a:t>
+            </a:r>
+            <a:r>
+              <a:rPr sz="1600" dirty="0" err="1">
                 <a:solidFill>
                   <a:srgbClr val="333333"/>
                 </a:solidFill>
                 <a:latin typeface="Calibri"/>
               </a:rPr>
-              <a:t>2.  Buildroot vs Yocto — the two main contenders</a:t>
-            </a:r>
-          </a:p>
-          <a:p>
-            <a:pPr>
-              <a:spcAft>
-                <a:spcPts val="600"/>
-              </a:spcAft>
-            </a:pPr>
-            <a:r>
-              <a:rPr sz="2000" b="0" i="0">
+              <a:t>BitBake</a:t>
+            </a:r>
+            <a:r>
+              <a:rPr sz="1600" dirty="0">
                 <a:solidFill>
                   <a:srgbClr val="333333"/>
                 </a:solidFill>
                 <a:latin typeface="Calibri"/>
               </a:rPr>
-              <a:t>3.  When to pick which</a:t>
-            </a:r>
-          </a:p>
-          <a:p>
-            <a:pPr>
-              <a:spcAft>
-                <a:spcPts val="600"/>
-              </a:spcAft>
-            </a:pPr>
-            <a:r>
-              <a:rPr sz="2000" b="0" i="0">
+              <a:t>, recipes, layers, </a:t>
+            </a:r>
+            <a:r>
+              <a:rPr sz="1600" dirty="0" err="1">
                 <a:solidFill>
                   <a:srgbClr val="333333"/>
                 </a:solidFill>
                 <a:latin typeface="Calibri"/>
               </a:rPr>
-              <a:t>4.  Cross-compilation fundamentals</a:t>
-            </a:r>
-          </a:p>
-          <a:p>
-            <a:pPr>
-              <a:spcAft>
-                <a:spcPts val="600"/>
-              </a:spcAft>
-            </a:pPr>
-            <a:r>
-              <a:rPr sz="2000" b="0" i="0">
-                <a:solidFill>
-                  <a:srgbClr val="333333"/>
-                </a:solidFill>
-                <a:latin typeface="Calibri"/>
-              </a:rPr>
-              <a:t>5.  Toolchain, sysroot, ABI, target triples</a:t>
-            </a:r>
-          </a:p>
-        </p:txBody>
-      </p:sp>
-    </p:spTree>
-  </p:cSld>
-  <p:clrMapOvr>
-    <a:masterClrMapping/>
-  </p:clrMapOvr>
-</p:sld>
-</file>
-
-<file path=ppt/slides/slide9.xml><?xml version="1.0" encoding="utf-8"?>
-<p:sld xmlns:a="http://schemas.openxmlformats.org/drawingml/2006/main" xmlns:p="http://schemas.openxmlformats.org/presentationml/2006/main" xmlns:r="http://schemas.openxmlformats.org/officeDocument/2006/relationships">
-  <p:cSld>
-    <p:spTree>
-      <p:nvGrpSpPr>
-        <p:cNvPr id="1" name=""/>
-        <p:cNvGrpSpPr/>
-        <p:nvPr/>
-      </p:nvGrpSpPr>
-      <p:grpSpPr/>
-      <p:sp>
-        <p:nvSpPr>
-          <p:cNvPr id="2" name="Title 1"/>
-          <p:cNvSpPr>
-            <a:spLocks noGrp="1"/>
-          </p:cNvSpPr>
-          <p:nvPr>
-            <p:ph type="title"/>
-          </p:nvPr>
-        </p:nvSpPr>
-        <p:spPr/>
-        <p:txBody>
-          <a:bodyPr/>
-          <a:lstStyle/>
-          <a:p>
-            <a:r>
-              <a:rPr sz="3200" b="1">
-                <a:solidFill>
-                  <a:srgbClr val="CC0066"/>
-                </a:solidFill>
-                <a:latin typeface="Calibri"/>
-              </a:rPr>
-              <a:t>The Embedded Linux Problem</a:t>
-            </a:r>
-          </a:p>
-        </p:txBody>
-      </p:sp>
-      <p:sp>
-        <p:nvSpPr>
-          <p:cNvPr id="3" name="TextBox 2"/>
-          <p:cNvSpPr txBox="1"/>
-          <p:nvPr/>
-        </p:nvSpPr>
-        <p:spPr>
-          <a:xfrm>
-            <a:off x="822960" y="1417320"/>
-            <a:ext cx="10515600" cy="365760"/>
-          </a:xfrm>
-          <a:prstGeom prst="rect">
-            <a:avLst/>
-          </a:prstGeom>
-          <a:noFill/>
-        </p:spPr>
-        <p:txBody>
-          <a:bodyPr wrap="square" anchor="t" lIns="45720" rIns="45720">
-            <a:spAutoFit/>
-          </a:bodyPr>
-          <a:lstStyle/>
-          <a:p>
-            <a:pPr algn="l"/>
-            <a:r>
-              <a:rPr sz="1500" b="0" i="1">
-                <a:solidFill>
-                  <a:srgbClr val="666666"/>
-                </a:solidFill>
-                <a:latin typeface="Calibri"/>
-              </a:rPr>
-              <a:t>Why we can't just 'apt install' our way to an embedded device.</a:t>
-            </a:r>
-          </a:p>
-        </p:txBody>
-      </p:sp>
-      <p:sp>
-        <p:nvSpPr>
-          <p:cNvPr id="4" name="TextBox 3"/>
-          <p:cNvSpPr txBox="1"/>
-          <p:nvPr/>
-        </p:nvSpPr>
-        <p:spPr>
-          <a:xfrm>
-            <a:off x="822960" y="1783080"/>
-            <a:ext cx="10515600" cy="4572000"/>
-          </a:xfrm>
-          <a:prstGeom prst="rect">
-            <a:avLst/>
-          </a:prstGeom>
-          <a:noFill/>
-        </p:spPr>
-        <p:txBody>
-          <a:bodyPr wrap="square" lIns="45720" rIns="45720">
-            <a:spAutoFit/>
-          </a:bodyPr>
-          <a:lstStyle/>
-          <a:p>
-            <a:pPr>
-              <a:spcAft>
-                <a:spcPts val="400"/>
-              </a:spcAft>
-            </a:pPr>
-            <a:r>
-              <a:rPr sz="1600" b="1" i="0">
-                <a:solidFill>
-                  <a:srgbClr val="CC0066"/>
-                </a:solidFill>
-                <a:latin typeface="Calibri"/>
-              </a:rPr>
-              <a:t>Desktop Linux assumes</a:t>
-            </a:r>
-          </a:p>
-          <a:p>
-            <a:pPr>
-              <a:spcAft>
-                <a:spcPts val="400"/>
-              </a:spcAft>
-            </a:pPr>
-            <a:r>
-              <a:rPr sz="1300" b="0" i="0">
-                <a:solidFill>
-                  <a:srgbClr val="333333"/>
-                </a:solidFill>
-                <a:latin typeface="Calibri"/>
-              </a:rPr>
-              <a:t>• Lots of RAM, lots of disk</a:t>
-            </a:r>
-          </a:p>
-          <a:p>
-            <a:pPr>
-              <a:spcAft>
-                <a:spcPts val="400"/>
-              </a:spcAft>
-            </a:pPr>
-            <a:r>
-              <a:rPr sz="1300" b="0" i="0">
-                <a:solidFill>
-                  <a:srgbClr val="333333"/>
-                </a:solidFill>
-                <a:latin typeface="Calibri"/>
-              </a:rPr>
-              <a:t>• A package manager with network access</a:t>
-            </a:r>
-          </a:p>
-          <a:p>
-            <a:pPr>
-              <a:spcAft>
-                <a:spcPts val="400"/>
-              </a:spcAft>
-            </a:pPr>
-            <a:r>
-              <a:rPr sz="1300" b="0" i="0">
-                <a:solidFill>
-                  <a:srgbClr val="333333"/>
-                </a:solidFill>
-                <a:latin typeface="Calibri"/>
-              </a:rPr>
-              <a:t>• Generic x86_64 hardware</a:t>
-            </a:r>
-          </a:p>
-          <a:p>
-            <a:pPr>
-              <a:spcAft>
-                <a:spcPts val="1000"/>
-              </a:spcAft>
-            </a:pPr>
-            <a:r>
-              <a:rPr sz="1300" b="0" i="0">
-                <a:solidFill>
-                  <a:srgbClr val="333333"/>
-                </a:solidFill>
-                <a:latin typeface="Calibri"/>
-              </a:rPr>
-              <a:t>• Someone is sitting at a keyboard</a:t>
-            </a:r>
-          </a:p>
-          <a:p>
-            <a:pPr>
-              <a:spcAft>
-                <a:spcPts val="400"/>
-              </a:spcAft>
-            </a:pPr>
-            <a:r>
-              <a:rPr sz="1600" b="1" i="0">
-                <a:solidFill>
-                  <a:srgbClr val="663399"/>
-                </a:solidFill>
-                <a:latin typeface="Calibri"/>
-              </a:rPr>
-              <a:t>Embedded Linux reality</a:t>
-            </a:r>
-          </a:p>
-          <a:p>
-            <a:pPr>
-              <a:spcAft>
-                <a:spcPts val="400"/>
-              </a:spcAft>
-            </a:pPr>
-            <a:r>
-              <a:rPr sz="1300" b="0" i="0">
-                <a:solidFill>
-                  <a:srgbClr val="333333"/>
-                </a:solidFill>
-                <a:latin typeface="Calibri"/>
-              </a:rPr>
-              <a:t>• Tight resources — 256 MB RAM, 1 GB flash is common</a:t>
-            </a:r>
-          </a:p>
-          <a:p>
-            <a:pPr>
-              <a:spcAft>
-                <a:spcPts val="400"/>
-              </a:spcAft>
-            </a:pPr>
-            <a:r>
-              <a:rPr sz="1300" b="0" i="0">
-                <a:solidFill>
-                  <a:srgbClr val="333333"/>
-                </a:solidFill>
-                <a:latin typeface="Calibri"/>
-              </a:rPr>
-              <a:t>• Custom hardware — ARM SoC, specific peripherals</a:t>
-            </a:r>
-          </a:p>
-          <a:p>
-            <a:pPr>
-              <a:spcAft>
-                <a:spcPts val="400"/>
-              </a:spcAft>
-            </a:pPr>
-            <a:r>
-              <a:rPr sz="1300" b="0" i="0">
-                <a:solidFill>
-                  <a:srgbClr val="333333"/>
-                </a:solidFill>
-                <a:latin typeface="Calibri"/>
-              </a:rPr>
-              <a:t>• Headless — no keyboard, often no display</a:t>
-            </a:r>
-          </a:p>
-          <a:p>
-            <a:pPr>
-              <a:spcAft>
-                <a:spcPts val="400"/>
-              </a:spcAft>
-            </a:pPr>
-            <a:r>
-              <a:rPr sz="1300" b="0" i="0">
-                <a:solidFill>
-                  <a:srgbClr val="333333"/>
-                </a:solidFill>
-                <a:latin typeface="Calibri"/>
-              </a:rPr>
-              <a:t>• Cross-compiled — build on x86, run on ARM</a:t>
-            </a:r>
-          </a:p>
-          <a:p>
-            <a:pPr>
-              <a:spcAft>
-                <a:spcPts val="1000"/>
-              </a:spcAft>
-            </a:pPr>
-            <a:r>
-              <a:rPr sz="1300" b="0" i="0">
-                <a:solidFill>
-                  <a:srgbClr val="333333"/>
-                </a:solidFill>
-                <a:latin typeface="Calibri"/>
-              </a:rPr>
-              <a:t>• Customer-shipped — must be reproducible, supportable for years</a:t>
-            </a:r>
-          </a:p>
-          <a:p>
-            <a:pPr>
-              <a:spcAft>
-                <a:spcPts val="400"/>
-              </a:spcAft>
-            </a:pPr>
-            <a:r>
-              <a:rPr sz="1400" b="1" i="0">
-                <a:solidFill>
-                  <a:srgbClr val="663399"/>
-                </a:solidFill>
-                <a:latin typeface="Calibri"/>
-              </a:rPr>
-              <a:t>So we need a build system that handles all of this end to end. That's where Buildroot and Yocto come in.</a:t>
-            </a:r>
+              <a:t>sstate</a:t>
+            </a:r>
+            <a:endParaRPr sz="1600" dirty="0">
+              <a:solidFill>
+                <a:srgbClr val="333333"/>
+              </a:solidFill>
+              <a:latin typeface="Calibri"/>
+            </a:endParaRPr>
           </a:p>
         </p:txBody>
       </p:sp>

</xml_diff>